<commit_message>
Fix standard template deck to widescreen
</commit_message>
<xml_diff>
--- a/books/Speaking with PowerPoint/revision/assets/model-slide-decks/process-business-standard-template-v2.pptx
+++ b/books/Speaking with PowerPoint/revision/assets/model-slide-decks/process-business-standard-template-v2.pptx
@@ -12,14 +12,14 @@
     <p:sldId id="260" r:id="rId6"/>
     <p:sldId id="261" r:id="rId7"/>
   </p:sldIdLst>
-  <p:sldSz cx="7315200" cy="5486400" type="B5JIS"/>
+  <p:sldSz cx="12192000" cy="6858000"/>
   <p:notesSz cx="6858000" cy="9144000"/>
   <p:defaultTextStyle>
     <a:defPPr>
       <a:defRPr lang="en-US"/>
     </a:defPPr>
-    <a:lvl1pPr marL="0" algn="l" defTabSz="614477" rtl="0" eaLnBrk="1" latinLnBrk="0" hangingPunct="1">
-      <a:defRPr sz="1210" kern="1200">
+    <a:lvl1pPr marL="0" algn="l" defTabSz="914400" rtl="0" eaLnBrk="1" latinLnBrk="0" hangingPunct="1">
+      <a:defRPr sz="1800" kern="1200">
         <a:solidFill>
           <a:schemeClr val="tx1"/>
         </a:solidFill>
@@ -28,8 +28,8 @@
         <a:cs typeface="+mn-cs"/>
       </a:defRPr>
     </a:lvl1pPr>
-    <a:lvl2pPr marL="307238" algn="l" defTabSz="614477" rtl="0" eaLnBrk="1" latinLnBrk="0" hangingPunct="1">
-      <a:defRPr sz="1210" kern="1200">
+    <a:lvl2pPr marL="457200" algn="l" defTabSz="914400" rtl="0" eaLnBrk="1" latinLnBrk="0" hangingPunct="1">
+      <a:defRPr sz="1800" kern="1200">
         <a:solidFill>
           <a:schemeClr val="tx1"/>
         </a:solidFill>
@@ -38,8 +38,8 @@
         <a:cs typeface="+mn-cs"/>
       </a:defRPr>
     </a:lvl2pPr>
-    <a:lvl3pPr marL="614477" algn="l" defTabSz="614477" rtl="0" eaLnBrk="1" latinLnBrk="0" hangingPunct="1">
-      <a:defRPr sz="1210" kern="1200">
+    <a:lvl3pPr marL="914400" algn="l" defTabSz="914400" rtl="0" eaLnBrk="1" latinLnBrk="0" hangingPunct="1">
+      <a:defRPr sz="1800" kern="1200">
         <a:solidFill>
           <a:schemeClr val="tx1"/>
         </a:solidFill>
@@ -48,8 +48,8 @@
         <a:cs typeface="+mn-cs"/>
       </a:defRPr>
     </a:lvl3pPr>
-    <a:lvl4pPr marL="921715" algn="l" defTabSz="614477" rtl="0" eaLnBrk="1" latinLnBrk="0" hangingPunct="1">
-      <a:defRPr sz="1210" kern="1200">
+    <a:lvl4pPr marL="1371600" algn="l" defTabSz="914400" rtl="0" eaLnBrk="1" latinLnBrk="0" hangingPunct="1">
+      <a:defRPr sz="1800" kern="1200">
         <a:solidFill>
           <a:schemeClr val="tx1"/>
         </a:solidFill>
@@ -58,8 +58,8 @@
         <a:cs typeface="+mn-cs"/>
       </a:defRPr>
     </a:lvl4pPr>
-    <a:lvl5pPr marL="1228954" algn="l" defTabSz="614477" rtl="0" eaLnBrk="1" latinLnBrk="0" hangingPunct="1">
-      <a:defRPr sz="1210" kern="1200">
+    <a:lvl5pPr marL="1828800" algn="l" defTabSz="914400" rtl="0" eaLnBrk="1" latinLnBrk="0" hangingPunct="1">
+      <a:defRPr sz="1800" kern="1200">
         <a:solidFill>
           <a:schemeClr val="tx1"/>
         </a:solidFill>
@@ -68,8 +68,8 @@
         <a:cs typeface="+mn-cs"/>
       </a:defRPr>
     </a:lvl5pPr>
-    <a:lvl6pPr marL="1536192" algn="l" defTabSz="614477" rtl="0" eaLnBrk="1" latinLnBrk="0" hangingPunct="1">
-      <a:defRPr sz="1210" kern="1200">
+    <a:lvl6pPr marL="2286000" algn="l" defTabSz="914400" rtl="0" eaLnBrk="1" latinLnBrk="0" hangingPunct="1">
+      <a:defRPr sz="1800" kern="1200">
         <a:solidFill>
           <a:schemeClr val="tx1"/>
         </a:solidFill>
@@ -78,8 +78,8 @@
         <a:cs typeface="+mn-cs"/>
       </a:defRPr>
     </a:lvl6pPr>
-    <a:lvl7pPr marL="1843430" algn="l" defTabSz="614477" rtl="0" eaLnBrk="1" latinLnBrk="0" hangingPunct="1">
-      <a:defRPr sz="1210" kern="1200">
+    <a:lvl7pPr marL="2743200" algn="l" defTabSz="914400" rtl="0" eaLnBrk="1" latinLnBrk="0" hangingPunct="1">
+      <a:defRPr sz="1800" kern="1200">
         <a:solidFill>
           <a:schemeClr val="tx1"/>
         </a:solidFill>
@@ -88,8 +88,8 @@
         <a:cs typeface="+mn-cs"/>
       </a:defRPr>
     </a:lvl7pPr>
-    <a:lvl8pPr marL="2150669" algn="l" defTabSz="614477" rtl="0" eaLnBrk="1" latinLnBrk="0" hangingPunct="1">
-      <a:defRPr sz="1210" kern="1200">
+    <a:lvl8pPr marL="3200400" algn="l" defTabSz="914400" rtl="0" eaLnBrk="1" latinLnBrk="0" hangingPunct="1">
+      <a:defRPr sz="1800" kern="1200">
         <a:solidFill>
           <a:schemeClr val="tx1"/>
         </a:solidFill>
@@ -98,8 +98,8 @@
         <a:cs typeface="+mn-cs"/>
       </a:defRPr>
     </a:lvl8pPr>
-    <a:lvl9pPr marL="2457907" algn="l" defTabSz="614477" rtl="0" eaLnBrk="1" latinLnBrk="0" hangingPunct="1">
-      <a:defRPr sz="1210" kern="1200">
+    <a:lvl9pPr marL="3657600" algn="l" defTabSz="914400" rtl="0" eaLnBrk="1" latinLnBrk="0" hangingPunct="1">
+      <a:defRPr sz="1800" kern="1200">
         <a:solidFill>
           <a:schemeClr val="tx1"/>
         </a:solidFill>
@@ -134,7 +134,7 @@
           <p:cNvPr id="2" name="Title 1">
             <a:extLst>
               <a:ext uri="{FF2B5EF4-FFF2-40B4-BE49-F238E27FC236}">
-                <a16:creationId xmlns:a16="http://schemas.microsoft.com/office/drawing/2014/main" id="{FCF2C742-085C-C0ED-26AB-73EA50D947F8}"/>
+                <a16:creationId xmlns:a16="http://schemas.microsoft.com/office/drawing/2014/main" id="{BEA4C3B7-D130-BA73-50F9-32B282A736EE}"/>
               </a:ext>
             </a:extLst>
           </p:cNvPr>
@@ -147,15 +147,15 @@
         </p:nvSpPr>
         <p:spPr>
           <a:xfrm>
-            <a:off x="914400" y="897890"/>
-            <a:ext cx="5486400" cy="1910080"/>
+            <a:off x="1524000" y="1122363"/>
+            <a:ext cx="9144000" cy="2387600"/>
           </a:xfrm>
         </p:spPr>
         <p:txBody>
           <a:bodyPr anchor="b"/>
           <a:lstStyle>
             <a:lvl1pPr algn="ctr">
-              <a:defRPr sz="3600"/>
+              <a:defRPr sz="6000"/>
             </a:lvl1pPr>
           </a:lstStyle>
           <a:p>
@@ -171,7 +171,7 @@
           <p:cNvPr id="3" name="Subtitle 2">
             <a:extLst>
               <a:ext uri="{FF2B5EF4-FFF2-40B4-BE49-F238E27FC236}">
-                <a16:creationId xmlns:a16="http://schemas.microsoft.com/office/drawing/2014/main" id="{1F470B35-7BE2-E2B0-DBC8-C2B16270ADAD}"/>
+                <a16:creationId xmlns:a16="http://schemas.microsoft.com/office/drawing/2014/main" id="{5D9A29E0-4E79-9150-F862-F29EADE0F1AA}"/>
               </a:ext>
             </a:extLst>
           </p:cNvPr>
@@ -184,8 +184,8 @@
         </p:nvSpPr>
         <p:spPr>
           <a:xfrm>
-            <a:off x="914400" y="2881630"/>
-            <a:ext cx="5486400" cy="1324610"/>
+            <a:off x="1524000" y="3602038"/>
+            <a:ext cx="9144000" cy="1655762"/>
           </a:xfrm>
         </p:spPr>
         <p:txBody>
@@ -193,39 +193,39 @@
           <a:lstStyle>
             <a:lvl1pPr marL="0" indent="0" algn="ctr">
               <a:buNone/>
-              <a:defRPr sz="1440"/>
+              <a:defRPr sz="2400"/>
             </a:lvl1pPr>
-            <a:lvl2pPr marL="274320" indent="0" algn="ctr">
-              <a:buNone/>
-              <a:defRPr sz="1200"/>
+            <a:lvl2pPr marL="457200" indent="0" algn="ctr">
+              <a:buNone/>
+              <a:defRPr sz="2000"/>
             </a:lvl2pPr>
-            <a:lvl3pPr marL="548640" indent="0" algn="ctr">
-              <a:buNone/>
-              <a:defRPr sz="1080"/>
+            <a:lvl3pPr marL="914400" indent="0" algn="ctr">
+              <a:buNone/>
+              <a:defRPr sz="1800"/>
             </a:lvl3pPr>
-            <a:lvl4pPr marL="822960" indent="0" algn="ctr">
-              <a:buNone/>
-              <a:defRPr sz="960"/>
+            <a:lvl4pPr marL="1371600" indent="0" algn="ctr">
+              <a:buNone/>
+              <a:defRPr sz="1600"/>
             </a:lvl4pPr>
-            <a:lvl5pPr marL="1097280" indent="0" algn="ctr">
-              <a:buNone/>
-              <a:defRPr sz="960"/>
+            <a:lvl5pPr marL="1828800" indent="0" algn="ctr">
+              <a:buNone/>
+              <a:defRPr sz="1600"/>
             </a:lvl5pPr>
-            <a:lvl6pPr marL="1371600" indent="0" algn="ctr">
-              <a:buNone/>
-              <a:defRPr sz="960"/>
+            <a:lvl6pPr marL="2286000" indent="0" algn="ctr">
+              <a:buNone/>
+              <a:defRPr sz="1600"/>
             </a:lvl6pPr>
-            <a:lvl7pPr marL="1645920" indent="0" algn="ctr">
-              <a:buNone/>
-              <a:defRPr sz="960"/>
+            <a:lvl7pPr marL="2743200" indent="0" algn="ctr">
+              <a:buNone/>
+              <a:defRPr sz="1600"/>
             </a:lvl7pPr>
-            <a:lvl8pPr marL="1920240" indent="0" algn="ctr">
-              <a:buNone/>
-              <a:defRPr sz="960"/>
+            <a:lvl8pPr marL="3200400" indent="0" algn="ctr">
+              <a:buNone/>
+              <a:defRPr sz="1600"/>
             </a:lvl8pPr>
-            <a:lvl9pPr marL="2194560" indent="0" algn="ctr">
-              <a:buNone/>
-              <a:defRPr sz="960"/>
+            <a:lvl9pPr marL="3657600" indent="0" algn="ctr">
+              <a:buNone/>
+              <a:defRPr sz="1600"/>
             </a:lvl9pPr>
           </a:lstStyle>
           <a:p>
@@ -241,7 +241,7 @@
           <p:cNvPr id="4" name="Date Placeholder 3">
             <a:extLst>
               <a:ext uri="{FF2B5EF4-FFF2-40B4-BE49-F238E27FC236}">
-                <a16:creationId xmlns:a16="http://schemas.microsoft.com/office/drawing/2014/main" id="{878E172E-DF50-C5CB-FF3B-66A614F3E789}"/>
+                <a16:creationId xmlns:a16="http://schemas.microsoft.com/office/drawing/2014/main" id="{F14A05DC-8F3F-1F9C-3E2C-1B435736562A}"/>
               </a:ext>
             </a:extLst>
           </p:cNvPr>
@@ -257,7 +257,7 @@
           <a:bodyPr/>
           <a:lstStyle/>
           <a:p>
-            <a:fld id="{35E6844C-3C51-4918-A9D5-3B7132835869}" type="datetimeFigureOut">
+            <a:fld id="{6E27AF6A-912D-4C46-A256-6E6A6FF02C93}" type="datetimeFigureOut">
               <a:rPr lang="en-US" smtClean="0"/>
               <a:t>8/13/2026</a:t>
             </a:fld>
@@ -270,7 +270,7 @@
           <p:cNvPr id="5" name="Footer Placeholder 4">
             <a:extLst>
               <a:ext uri="{FF2B5EF4-FFF2-40B4-BE49-F238E27FC236}">
-                <a16:creationId xmlns:a16="http://schemas.microsoft.com/office/drawing/2014/main" id="{D79E3A88-D888-4CE5-2D5C-05F482338E32}"/>
+                <a16:creationId xmlns:a16="http://schemas.microsoft.com/office/drawing/2014/main" id="{0C60BD04-7C6F-C0C2-8C2B-5DB0B19A33F4}"/>
               </a:ext>
             </a:extLst>
           </p:cNvPr>
@@ -295,7 +295,7 @@
           <p:cNvPr id="6" name="Slide Number Placeholder 5">
             <a:extLst>
               <a:ext uri="{FF2B5EF4-FFF2-40B4-BE49-F238E27FC236}">
-                <a16:creationId xmlns:a16="http://schemas.microsoft.com/office/drawing/2014/main" id="{A218B14A-F323-3214-215D-58AA4A46A8AA}"/>
+                <a16:creationId xmlns:a16="http://schemas.microsoft.com/office/drawing/2014/main" id="{E88C0AEF-5B4E-CD3C-E2AF-B06119F1BB1E}"/>
               </a:ext>
             </a:extLst>
           </p:cNvPr>
@@ -311,7 +311,7 @@
           <a:bodyPr/>
           <a:lstStyle/>
           <a:p>
-            <a:fld id="{F3AC3495-A25B-46F5-9D8B-F07130A6FEDC}" type="slidenum">
+            <a:fld id="{95780A41-0D26-45C0-A0CB-A6488D853006}" type="slidenum">
               <a:rPr lang="en-US" smtClean="0"/>
               <a:t>‹#›</a:t>
             </a:fld>
@@ -322,7 +322,7 @@
     </p:spTree>
     <p:extLst>
       <p:ext uri="{BB962C8B-B14F-4D97-AF65-F5344CB8AC3E}">
-        <p14:creationId xmlns:p14="http://schemas.microsoft.com/office/powerpoint/2010/main" val="338755911"/>
+        <p14:creationId xmlns:p14="http://schemas.microsoft.com/office/powerpoint/2010/main" val="3787716576"/>
       </p:ext>
     </p:extLst>
   </p:cSld>
@@ -354,7 +354,7 @@
           <p:cNvPr id="2" name="Title 1">
             <a:extLst>
               <a:ext uri="{FF2B5EF4-FFF2-40B4-BE49-F238E27FC236}">
-                <a16:creationId xmlns:a16="http://schemas.microsoft.com/office/drawing/2014/main" id="{73DBF47B-6F4B-A16C-5CE0-85A1B4D1A599}"/>
+                <a16:creationId xmlns:a16="http://schemas.microsoft.com/office/drawing/2014/main" id="{1F979D74-5595-24C7-AE37-B7312577C036}"/>
               </a:ext>
             </a:extLst>
           </p:cNvPr>
@@ -382,7 +382,7 @@
           <p:cNvPr id="3" name="Vertical Text Placeholder 2">
             <a:extLst>
               <a:ext uri="{FF2B5EF4-FFF2-40B4-BE49-F238E27FC236}">
-                <a16:creationId xmlns:a16="http://schemas.microsoft.com/office/drawing/2014/main" id="{6D2E65FC-6A95-0E36-4AAF-BC9AA4EEAA5E}"/>
+                <a16:creationId xmlns:a16="http://schemas.microsoft.com/office/drawing/2014/main" id="{BF6F7A3B-CACE-F6AE-7A67-7C563B67111F}"/>
               </a:ext>
             </a:extLst>
           </p:cNvPr>
@@ -439,7 +439,7 @@
           <p:cNvPr id="4" name="Date Placeholder 3">
             <a:extLst>
               <a:ext uri="{FF2B5EF4-FFF2-40B4-BE49-F238E27FC236}">
-                <a16:creationId xmlns:a16="http://schemas.microsoft.com/office/drawing/2014/main" id="{03EC116C-76BD-59DE-8C33-4FC2BD78D312}"/>
+                <a16:creationId xmlns:a16="http://schemas.microsoft.com/office/drawing/2014/main" id="{B351FBF3-5935-80CE-45FB-F08E1731260D}"/>
               </a:ext>
             </a:extLst>
           </p:cNvPr>
@@ -455,7 +455,7 @@
           <a:bodyPr/>
           <a:lstStyle/>
           <a:p>
-            <a:fld id="{35E6844C-3C51-4918-A9D5-3B7132835869}" type="datetimeFigureOut">
+            <a:fld id="{6E27AF6A-912D-4C46-A256-6E6A6FF02C93}" type="datetimeFigureOut">
               <a:rPr lang="en-US" smtClean="0"/>
               <a:t>8/13/2026</a:t>
             </a:fld>
@@ -468,7 +468,7 @@
           <p:cNvPr id="5" name="Footer Placeholder 4">
             <a:extLst>
               <a:ext uri="{FF2B5EF4-FFF2-40B4-BE49-F238E27FC236}">
-                <a16:creationId xmlns:a16="http://schemas.microsoft.com/office/drawing/2014/main" id="{C6CF7442-4A64-BFBA-35BD-B0CB50AD49E8}"/>
+                <a16:creationId xmlns:a16="http://schemas.microsoft.com/office/drawing/2014/main" id="{9295962D-DC04-148A-98F5-79D7F3B57C15}"/>
               </a:ext>
             </a:extLst>
           </p:cNvPr>
@@ -493,7 +493,7 @@
           <p:cNvPr id="6" name="Slide Number Placeholder 5">
             <a:extLst>
               <a:ext uri="{FF2B5EF4-FFF2-40B4-BE49-F238E27FC236}">
-                <a16:creationId xmlns:a16="http://schemas.microsoft.com/office/drawing/2014/main" id="{733F493A-FAC6-AB49-D9E8-94DFAAC3EC06}"/>
+                <a16:creationId xmlns:a16="http://schemas.microsoft.com/office/drawing/2014/main" id="{540439FF-5698-5FAB-CBEF-E59CA7380F4D}"/>
               </a:ext>
             </a:extLst>
           </p:cNvPr>
@@ -509,7 +509,7 @@
           <a:bodyPr/>
           <a:lstStyle/>
           <a:p>
-            <a:fld id="{F3AC3495-A25B-46F5-9D8B-F07130A6FEDC}" type="slidenum">
+            <a:fld id="{95780A41-0D26-45C0-A0CB-A6488D853006}" type="slidenum">
               <a:rPr lang="en-US" smtClean="0"/>
               <a:t>‹#›</a:t>
             </a:fld>
@@ -520,7 +520,7 @@
     </p:spTree>
     <p:extLst>
       <p:ext uri="{BB962C8B-B14F-4D97-AF65-F5344CB8AC3E}">
-        <p14:creationId xmlns:p14="http://schemas.microsoft.com/office/powerpoint/2010/main" val="1353243880"/>
+        <p14:creationId xmlns:p14="http://schemas.microsoft.com/office/powerpoint/2010/main" val="3191072786"/>
       </p:ext>
     </p:extLst>
   </p:cSld>
@@ -552,7 +552,7 @@
           <p:cNvPr id="2" name="Vertical Title 1">
             <a:extLst>
               <a:ext uri="{FF2B5EF4-FFF2-40B4-BE49-F238E27FC236}">
-                <a16:creationId xmlns:a16="http://schemas.microsoft.com/office/drawing/2014/main" id="{D7FEBF90-63BF-B703-894E-FDFB5F5AB6D7}"/>
+                <a16:creationId xmlns:a16="http://schemas.microsoft.com/office/drawing/2014/main" id="{B41136EC-00FD-22A0-89D7-8CA6E71CAD4B}"/>
               </a:ext>
             </a:extLst>
           </p:cNvPr>
@@ -565,8 +565,8 @@
         </p:nvSpPr>
         <p:spPr>
           <a:xfrm>
-            <a:off x="5234940" y="292100"/>
-            <a:ext cx="1577340" cy="4649470"/>
+            <a:off x="8724900" y="365125"/>
+            <a:ext cx="2628900" cy="5811838"/>
           </a:xfrm>
         </p:spPr>
         <p:txBody>
@@ -585,7 +585,7 @@
           <p:cNvPr id="3" name="Vertical Text Placeholder 2">
             <a:extLst>
               <a:ext uri="{FF2B5EF4-FFF2-40B4-BE49-F238E27FC236}">
-                <a16:creationId xmlns:a16="http://schemas.microsoft.com/office/drawing/2014/main" id="{0B757F8E-E447-F55F-2319-3C0A4E921C93}"/>
+                <a16:creationId xmlns:a16="http://schemas.microsoft.com/office/drawing/2014/main" id="{FDBABE3A-11D9-AF93-75CD-9A5BF4DA11D3}"/>
               </a:ext>
             </a:extLst>
           </p:cNvPr>
@@ -598,8 +598,8 @@
         </p:nvSpPr>
         <p:spPr>
           <a:xfrm>
-            <a:off x="502920" y="292100"/>
-            <a:ext cx="4640580" cy="4649470"/>
+            <a:off x="838200" y="365125"/>
+            <a:ext cx="7734300" cy="5811838"/>
           </a:xfrm>
         </p:spPr>
         <p:txBody>
@@ -647,7 +647,7 @@
           <p:cNvPr id="4" name="Date Placeholder 3">
             <a:extLst>
               <a:ext uri="{FF2B5EF4-FFF2-40B4-BE49-F238E27FC236}">
-                <a16:creationId xmlns:a16="http://schemas.microsoft.com/office/drawing/2014/main" id="{AB1F9C8E-A947-3945-CB9A-253C77B1DCA4}"/>
+                <a16:creationId xmlns:a16="http://schemas.microsoft.com/office/drawing/2014/main" id="{34EF4ED4-35AE-9C9F-555C-83F8E70F5DA4}"/>
               </a:ext>
             </a:extLst>
           </p:cNvPr>
@@ -663,7 +663,7 @@
           <a:bodyPr/>
           <a:lstStyle/>
           <a:p>
-            <a:fld id="{35E6844C-3C51-4918-A9D5-3B7132835869}" type="datetimeFigureOut">
+            <a:fld id="{6E27AF6A-912D-4C46-A256-6E6A6FF02C93}" type="datetimeFigureOut">
               <a:rPr lang="en-US" smtClean="0"/>
               <a:t>8/13/2026</a:t>
             </a:fld>
@@ -676,7 +676,7 @@
           <p:cNvPr id="5" name="Footer Placeholder 4">
             <a:extLst>
               <a:ext uri="{FF2B5EF4-FFF2-40B4-BE49-F238E27FC236}">
-                <a16:creationId xmlns:a16="http://schemas.microsoft.com/office/drawing/2014/main" id="{AF3AE84A-9BE3-A987-64A3-D929F984CC05}"/>
+                <a16:creationId xmlns:a16="http://schemas.microsoft.com/office/drawing/2014/main" id="{46C640E2-4A1D-B657-F503-27C1BCDEC29B}"/>
               </a:ext>
             </a:extLst>
           </p:cNvPr>
@@ -701,7 +701,7 @@
           <p:cNvPr id="6" name="Slide Number Placeholder 5">
             <a:extLst>
               <a:ext uri="{FF2B5EF4-FFF2-40B4-BE49-F238E27FC236}">
-                <a16:creationId xmlns:a16="http://schemas.microsoft.com/office/drawing/2014/main" id="{A1222D91-FA05-2177-81E5-C656ABC30A58}"/>
+                <a16:creationId xmlns:a16="http://schemas.microsoft.com/office/drawing/2014/main" id="{988C4826-2353-67A5-4733-87AFD3CD42FD}"/>
               </a:ext>
             </a:extLst>
           </p:cNvPr>
@@ -717,7 +717,7 @@
           <a:bodyPr/>
           <a:lstStyle/>
           <a:p>
-            <a:fld id="{F3AC3495-A25B-46F5-9D8B-F07130A6FEDC}" type="slidenum">
+            <a:fld id="{95780A41-0D26-45C0-A0CB-A6488D853006}" type="slidenum">
               <a:rPr lang="en-US" smtClean="0"/>
               <a:t>‹#›</a:t>
             </a:fld>
@@ -728,7 +728,7 @@
     </p:spTree>
     <p:extLst>
       <p:ext uri="{BB962C8B-B14F-4D97-AF65-F5344CB8AC3E}">
-        <p14:creationId xmlns:p14="http://schemas.microsoft.com/office/powerpoint/2010/main" val="1551948803"/>
+        <p14:creationId xmlns:p14="http://schemas.microsoft.com/office/powerpoint/2010/main" val="1294063631"/>
       </p:ext>
     </p:extLst>
   </p:cSld>
@@ -760,7 +760,7 @@
           <p:cNvPr id="2" name="Title 1">
             <a:extLst>
               <a:ext uri="{FF2B5EF4-FFF2-40B4-BE49-F238E27FC236}">
-                <a16:creationId xmlns:a16="http://schemas.microsoft.com/office/drawing/2014/main" id="{695014FF-5BFE-245D-3230-79B1AB0C7D2C}"/>
+                <a16:creationId xmlns:a16="http://schemas.microsoft.com/office/drawing/2014/main" id="{A6E19B0E-1DA0-5713-58DB-C64EDB3FF359}"/>
               </a:ext>
             </a:extLst>
           </p:cNvPr>
@@ -788,7 +788,7 @@
           <p:cNvPr id="3" name="Text Placeholder 2">
             <a:extLst>
               <a:ext uri="{FF2B5EF4-FFF2-40B4-BE49-F238E27FC236}">
-                <a16:creationId xmlns:a16="http://schemas.microsoft.com/office/drawing/2014/main" id="{7D8E4FD2-4D66-5355-2BA4-5C9F1DFA08E6}"/>
+                <a16:creationId xmlns:a16="http://schemas.microsoft.com/office/drawing/2014/main" id="{94ADBF3C-A7EF-EC83-64CA-F5BF88061A29}"/>
               </a:ext>
             </a:extLst>
           </p:cNvPr>
@@ -845,7 +845,7 @@
           <p:cNvPr id="4" name="Date Placeholder 3">
             <a:extLst>
               <a:ext uri="{FF2B5EF4-FFF2-40B4-BE49-F238E27FC236}">
-                <a16:creationId xmlns:a16="http://schemas.microsoft.com/office/drawing/2014/main" id="{0612B6DD-FFFE-542D-666A-C4789C2B4CD1}"/>
+                <a16:creationId xmlns:a16="http://schemas.microsoft.com/office/drawing/2014/main" id="{593F8877-467A-F03C-ED8E-36231A790A83}"/>
               </a:ext>
             </a:extLst>
           </p:cNvPr>
@@ -861,7 +861,7 @@
           <a:bodyPr/>
           <a:lstStyle/>
           <a:p>
-            <a:fld id="{35E6844C-3C51-4918-A9D5-3B7132835869}" type="datetimeFigureOut">
+            <a:fld id="{6E27AF6A-912D-4C46-A256-6E6A6FF02C93}" type="datetimeFigureOut">
               <a:rPr lang="en-US" smtClean="0"/>
               <a:t>8/13/2026</a:t>
             </a:fld>
@@ -874,7 +874,7 @@
           <p:cNvPr id="5" name="Footer Placeholder 4">
             <a:extLst>
               <a:ext uri="{FF2B5EF4-FFF2-40B4-BE49-F238E27FC236}">
-                <a16:creationId xmlns:a16="http://schemas.microsoft.com/office/drawing/2014/main" id="{E2EB23D5-F59C-3159-D97F-F2A4E6C33E09}"/>
+                <a16:creationId xmlns:a16="http://schemas.microsoft.com/office/drawing/2014/main" id="{B9FB6D90-ABA3-5EDB-292D-7478DBF3AB37}"/>
               </a:ext>
             </a:extLst>
           </p:cNvPr>
@@ -899,7 +899,7 @@
           <p:cNvPr id="6" name="Slide Number Placeholder 5">
             <a:extLst>
               <a:ext uri="{FF2B5EF4-FFF2-40B4-BE49-F238E27FC236}">
-                <a16:creationId xmlns:a16="http://schemas.microsoft.com/office/drawing/2014/main" id="{069BB5EF-66E8-AA08-B5A0-48F66C210904}"/>
+                <a16:creationId xmlns:a16="http://schemas.microsoft.com/office/drawing/2014/main" id="{657B6F0B-1E14-D16A-B808-E5C71086C18D}"/>
               </a:ext>
             </a:extLst>
           </p:cNvPr>
@@ -915,7 +915,7 @@
           <a:bodyPr/>
           <a:lstStyle/>
           <a:p>
-            <a:fld id="{F3AC3495-A25B-46F5-9D8B-F07130A6FEDC}" type="slidenum">
+            <a:fld id="{95780A41-0D26-45C0-A0CB-A6488D853006}" type="slidenum">
               <a:rPr lang="en-US" smtClean="0"/>
               <a:t>‹#›</a:t>
             </a:fld>
@@ -926,7 +926,7 @@
     </p:spTree>
     <p:extLst>
       <p:ext uri="{BB962C8B-B14F-4D97-AF65-F5344CB8AC3E}">
-        <p14:creationId xmlns:p14="http://schemas.microsoft.com/office/powerpoint/2010/main" val="2848479965"/>
+        <p14:creationId xmlns:p14="http://schemas.microsoft.com/office/powerpoint/2010/main" val="1374149437"/>
       </p:ext>
     </p:extLst>
   </p:cSld>
@@ -958,7 +958,7 @@
           <p:cNvPr id="2" name="Title 1">
             <a:extLst>
               <a:ext uri="{FF2B5EF4-FFF2-40B4-BE49-F238E27FC236}">
-                <a16:creationId xmlns:a16="http://schemas.microsoft.com/office/drawing/2014/main" id="{1BEAC66F-28E2-6C56-3D99-F6D5C0CF095A}"/>
+                <a16:creationId xmlns:a16="http://schemas.microsoft.com/office/drawing/2014/main" id="{9D49357F-1862-F43D-772E-0D5AAF6D98B9}"/>
               </a:ext>
             </a:extLst>
           </p:cNvPr>
@@ -986,7 +986,7 @@
           <p:cNvPr id="3" name="Content Placeholder 2">
             <a:extLst>
               <a:ext uri="{FF2B5EF4-FFF2-40B4-BE49-F238E27FC236}">
-                <a16:creationId xmlns:a16="http://schemas.microsoft.com/office/drawing/2014/main" id="{F450F6DC-4423-C1E3-B4F1-AABEE28CF7F2}"/>
+                <a16:creationId xmlns:a16="http://schemas.microsoft.com/office/drawing/2014/main" id="{91811BA2-B405-4EB7-4A50-C405F38FCF3B}"/>
               </a:ext>
             </a:extLst>
           </p:cNvPr>
@@ -1043,7 +1043,7 @@
           <p:cNvPr id="4" name="Date Placeholder 3">
             <a:extLst>
               <a:ext uri="{FF2B5EF4-FFF2-40B4-BE49-F238E27FC236}">
-                <a16:creationId xmlns:a16="http://schemas.microsoft.com/office/drawing/2014/main" id="{99AC13C2-52B1-2738-8A6C-A618B5433FC8}"/>
+                <a16:creationId xmlns:a16="http://schemas.microsoft.com/office/drawing/2014/main" id="{0B9609E7-A2B3-A06E-CD5E-88A220EC47F7}"/>
               </a:ext>
             </a:extLst>
           </p:cNvPr>
@@ -1059,7 +1059,7 @@
           <a:bodyPr/>
           <a:lstStyle/>
           <a:p>
-            <a:fld id="{35E6844C-3C51-4918-A9D5-3B7132835869}" type="datetimeFigureOut">
+            <a:fld id="{6E27AF6A-912D-4C46-A256-6E6A6FF02C93}" type="datetimeFigureOut">
               <a:rPr lang="en-US" smtClean="0"/>
               <a:t>8/13/2026</a:t>
             </a:fld>
@@ -1072,7 +1072,7 @@
           <p:cNvPr id="5" name="Footer Placeholder 4">
             <a:extLst>
               <a:ext uri="{FF2B5EF4-FFF2-40B4-BE49-F238E27FC236}">
-                <a16:creationId xmlns:a16="http://schemas.microsoft.com/office/drawing/2014/main" id="{CC91C030-4DB6-3C86-27B2-865A41E2B8B9}"/>
+                <a16:creationId xmlns:a16="http://schemas.microsoft.com/office/drawing/2014/main" id="{B89320F3-D592-226C-7EE4-111F0F1A0B86}"/>
               </a:ext>
             </a:extLst>
           </p:cNvPr>
@@ -1097,7 +1097,7 @@
           <p:cNvPr id="6" name="Slide Number Placeholder 5">
             <a:extLst>
               <a:ext uri="{FF2B5EF4-FFF2-40B4-BE49-F238E27FC236}">
-                <a16:creationId xmlns:a16="http://schemas.microsoft.com/office/drawing/2014/main" id="{EAA093FC-2931-4DEF-4D87-68A179620F4B}"/>
+                <a16:creationId xmlns:a16="http://schemas.microsoft.com/office/drawing/2014/main" id="{6BB10309-96BD-EFEA-E8C3-5B8B0B778452}"/>
               </a:ext>
             </a:extLst>
           </p:cNvPr>
@@ -1113,7 +1113,7 @@
           <a:bodyPr/>
           <a:lstStyle/>
           <a:p>
-            <a:fld id="{F3AC3495-A25B-46F5-9D8B-F07130A6FEDC}" type="slidenum">
+            <a:fld id="{95780A41-0D26-45C0-A0CB-A6488D853006}" type="slidenum">
               <a:rPr lang="en-US" smtClean="0"/>
               <a:t>‹#›</a:t>
             </a:fld>
@@ -1124,7 +1124,7 @@
     </p:spTree>
     <p:extLst>
       <p:ext uri="{BB962C8B-B14F-4D97-AF65-F5344CB8AC3E}">
-        <p14:creationId xmlns:p14="http://schemas.microsoft.com/office/powerpoint/2010/main" val="1601099198"/>
+        <p14:creationId xmlns:p14="http://schemas.microsoft.com/office/powerpoint/2010/main" val="1692146384"/>
       </p:ext>
     </p:extLst>
   </p:cSld>
@@ -1156,7 +1156,7 @@
           <p:cNvPr id="2" name="Title 1">
             <a:extLst>
               <a:ext uri="{FF2B5EF4-FFF2-40B4-BE49-F238E27FC236}">
-                <a16:creationId xmlns:a16="http://schemas.microsoft.com/office/drawing/2014/main" id="{107579DA-E51F-77B3-D3C5-E3FDA401C248}"/>
+                <a16:creationId xmlns:a16="http://schemas.microsoft.com/office/drawing/2014/main" id="{4A68D035-929D-B28D-1290-6D6955246B8A}"/>
               </a:ext>
             </a:extLst>
           </p:cNvPr>
@@ -1169,15 +1169,15 @@
         </p:nvSpPr>
         <p:spPr>
           <a:xfrm>
-            <a:off x="499110" y="1367791"/>
-            <a:ext cx="6309360" cy="2282190"/>
+            <a:off x="831850" y="1709738"/>
+            <a:ext cx="10515600" cy="2852737"/>
           </a:xfrm>
         </p:spPr>
         <p:txBody>
           <a:bodyPr anchor="b"/>
           <a:lstStyle>
             <a:lvl1pPr>
-              <a:defRPr sz="3600"/>
+              <a:defRPr sz="6000"/>
             </a:lvl1pPr>
           </a:lstStyle>
           <a:p>
@@ -1193,7 +1193,7 @@
           <p:cNvPr id="3" name="Text Placeholder 2">
             <a:extLst>
               <a:ext uri="{FF2B5EF4-FFF2-40B4-BE49-F238E27FC236}">
-                <a16:creationId xmlns:a16="http://schemas.microsoft.com/office/drawing/2014/main" id="{2EF068A8-1ACA-208A-AB90-925976E5588D}"/>
+                <a16:creationId xmlns:a16="http://schemas.microsoft.com/office/drawing/2014/main" id="{8CCA0360-EE35-AC34-5560-4ADF982481B2}"/>
               </a:ext>
             </a:extLst>
           </p:cNvPr>
@@ -1206,8 +1206,8 @@
         </p:nvSpPr>
         <p:spPr>
           <a:xfrm>
-            <a:off x="499110" y="3671571"/>
-            <a:ext cx="6309360" cy="1200150"/>
+            <a:off x="831850" y="4589463"/>
+            <a:ext cx="10515600" cy="1500187"/>
           </a:xfrm>
         </p:spPr>
         <p:txBody>
@@ -1215,7 +1215,7 @@
           <a:lstStyle>
             <a:lvl1pPr marL="0" indent="0">
               <a:buNone/>
-              <a:defRPr sz="1440">
+              <a:defRPr sz="2400">
                 <a:solidFill>
                   <a:schemeClr val="tx1">
                     <a:tint val="82000"/>
@@ -1223,9 +1223,9 @@
                 </a:solidFill>
               </a:defRPr>
             </a:lvl1pPr>
-            <a:lvl2pPr marL="274320" indent="0">
-              <a:buNone/>
-              <a:defRPr sz="1200">
+            <a:lvl2pPr marL="457200" indent="0">
+              <a:buNone/>
+              <a:defRPr sz="2000">
                 <a:solidFill>
                   <a:schemeClr val="tx1">
                     <a:tint val="82000"/>
@@ -1233,9 +1233,9 @@
                 </a:solidFill>
               </a:defRPr>
             </a:lvl2pPr>
-            <a:lvl3pPr marL="548640" indent="0">
-              <a:buNone/>
-              <a:defRPr sz="1080">
+            <a:lvl3pPr marL="914400" indent="0">
+              <a:buNone/>
+              <a:defRPr sz="1800">
                 <a:solidFill>
                   <a:schemeClr val="tx1">
                     <a:tint val="82000"/>
@@ -1243,9 +1243,9 @@
                 </a:solidFill>
               </a:defRPr>
             </a:lvl3pPr>
-            <a:lvl4pPr marL="822960" indent="0">
-              <a:buNone/>
-              <a:defRPr sz="960">
+            <a:lvl4pPr marL="1371600" indent="0">
+              <a:buNone/>
+              <a:defRPr sz="1600">
                 <a:solidFill>
                   <a:schemeClr val="tx1">
                     <a:tint val="82000"/>
@@ -1253,9 +1253,9 @@
                 </a:solidFill>
               </a:defRPr>
             </a:lvl4pPr>
-            <a:lvl5pPr marL="1097280" indent="0">
-              <a:buNone/>
-              <a:defRPr sz="960">
+            <a:lvl5pPr marL="1828800" indent="0">
+              <a:buNone/>
+              <a:defRPr sz="1600">
                 <a:solidFill>
                   <a:schemeClr val="tx1">
                     <a:tint val="82000"/>
@@ -1263,9 +1263,9 @@
                 </a:solidFill>
               </a:defRPr>
             </a:lvl5pPr>
-            <a:lvl6pPr marL="1371600" indent="0">
-              <a:buNone/>
-              <a:defRPr sz="960">
+            <a:lvl6pPr marL="2286000" indent="0">
+              <a:buNone/>
+              <a:defRPr sz="1600">
                 <a:solidFill>
                   <a:schemeClr val="tx1">
                     <a:tint val="82000"/>
@@ -1273,9 +1273,9 @@
                 </a:solidFill>
               </a:defRPr>
             </a:lvl6pPr>
-            <a:lvl7pPr marL="1645920" indent="0">
-              <a:buNone/>
-              <a:defRPr sz="960">
+            <a:lvl7pPr marL="2743200" indent="0">
+              <a:buNone/>
+              <a:defRPr sz="1600">
                 <a:solidFill>
                   <a:schemeClr val="tx1">
                     <a:tint val="82000"/>
@@ -1283,9 +1283,9 @@
                 </a:solidFill>
               </a:defRPr>
             </a:lvl7pPr>
-            <a:lvl8pPr marL="1920240" indent="0">
-              <a:buNone/>
-              <a:defRPr sz="960">
+            <a:lvl8pPr marL="3200400" indent="0">
+              <a:buNone/>
+              <a:defRPr sz="1600">
                 <a:solidFill>
                   <a:schemeClr val="tx1">
                     <a:tint val="82000"/>
@@ -1293,9 +1293,9 @@
                 </a:solidFill>
               </a:defRPr>
             </a:lvl8pPr>
-            <a:lvl9pPr marL="2194560" indent="0">
-              <a:buNone/>
-              <a:defRPr sz="960">
+            <a:lvl9pPr marL="3657600" indent="0">
+              <a:buNone/>
+              <a:defRPr sz="1600">
                 <a:solidFill>
                   <a:schemeClr val="tx1">
                     <a:tint val="82000"/>
@@ -1318,7 +1318,7 @@
           <p:cNvPr id="4" name="Date Placeholder 3">
             <a:extLst>
               <a:ext uri="{FF2B5EF4-FFF2-40B4-BE49-F238E27FC236}">
-                <a16:creationId xmlns:a16="http://schemas.microsoft.com/office/drawing/2014/main" id="{A65DB34E-948B-0E35-4856-5841B7408C66}"/>
+                <a16:creationId xmlns:a16="http://schemas.microsoft.com/office/drawing/2014/main" id="{6AF5370F-2907-54D1-7DF9-669420E1ACBE}"/>
               </a:ext>
             </a:extLst>
           </p:cNvPr>
@@ -1334,7 +1334,7 @@
           <a:bodyPr/>
           <a:lstStyle/>
           <a:p>
-            <a:fld id="{35E6844C-3C51-4918-A9D5-3B7132835869}" type="datetimeFigureOut">
+            <a:fld id="{6E27AF6A-912D-4C46-A256-6E6A6FF02C93}" type="datetimeFigureOut">
               <a:rPr lang="en-US" smtClean="0"/>
               <a:t>8/13/2026</a:t>
             </a:fld>
@@ -1347,7 +1347,7 @@
           <p:cNvPr id="5" name="Footer Placeholder 4">
             <a:extLst>
               <a:ext uri="{FF2B5EF4-FFF2-40B4-BE49-F238E27FC236}">
-                <a16:creationId xmlns:a16="http://schemas.microsoft.com/office/drawing/2014/main" id="{C7FEEF8F-9B84-ABE3-C87B-FBCCFE490FA5}"/>
+                <a16:creationId xmlns:a16="http://schemas.microsoft.com/office/drawing/2014/main" id="{D7219513-2AFA-7595-2A55-E40D3410A386}"/>
               </a:ext>
             </a:extLst>
           </p:cNvPr>
@@ -1372,7 +1372,7 @@
           <p:cNvPr id="6" name="Slide Number Placeholder 5">
             <a:extLst>
               <a:ext uri="{FF2B5EF4-FFF2-40B4-BE49-F238E27FC236}">
-                <a16:creationId xmlns:a16="http://schemas.microsoft.com/office/drawing/2014/main" id="{9D9B5119-0304-4553-D094-983F1D67C042}"/>
+                <a16:creationId xmlns:a16="http://schemas.microsoft.com/office/drawing/2014/main" id="{9DC4C88C-6199-F476-7BB6-DE171E92F9C1}"/>
               </a:ext>
             </a:extLst>
           </p:cNvPr>
@@ -1388,7 +1388,7 @@
           <a:bodyPr/>
           <a:lstStyle/>
           <a:p>
-            <a:fld id="{F3AC3495-A25B-46F5-9D8B-F07130A6FEDC}" type="slidenum">
+            <a:fld id="{95780A41-0D26-45C0-A0CB-A6488D853006}" type="slidenum">
               <a:rPr lang="en-US" smtClean="0"/>
               <a:t>‹#›</a:t>
             </a:fld>
@@ -1399,7 +1399,7 @@
     </p:spTree>
     <p:extLst>
       <p:ext uri="{BB962C8B-B14F-4D97-AF65-F5344CB8AC3E}">
-        <p14:creationId xmlns:p14="http://schemas.microsoft.com/office/powerpoint/2010/main" val="2830836594"/>
+        <p14:creationId xmlns:p14="http://schemas.microsoft.com/office/powerpoint/2010/main" val="2669082398"/>
       </p:ext>
     </p:extLst>
   </p:cSld>
@@ -1431,7 +1431,7 @@
           <p:cNvPr id="2" name="Title 1">
             <a:extLst>
               <a:ext uri="{FF2B5EF4-FFF2-40B4-BE49-F238E27FC236}">
-                <a16:creationId xmlns:a16="http://schemas.microsoft.com/office/drawing/2014/main" id="{8AC00CD0-F4B9-24F1-BE20-0BF39767E855}"/>
+                <a16:creationId xmlns:a16="http://schemas.microsoft.com/office/drawing/2014/main" id="{88E22EB7-F605-93F1-9EFD-C6C94C512BC3}"/>
               </a:ext>
             </a:extLst>
           </p:cNvPr>
@@ -1459,7 +1459,7 @@
           <p:cNvPr id="3" name="Content Placeholder 2">
             <a:extLst>
               <a:ext uri="{FF2B5EF4-FFF2-40B4-BE49-F238E27FC236}">
-                <a16:creationId xmlns:a16="http://schemas.microsoft.com/office/drawing/2014/main" id="{14874E69-9548-4AC9-72BD-D9FC9F94AF67}"/>
+                <a16:creationId xmlns:a16="http://schemas.microsoft.com/office/drawing/2014/main" id="{A97AA605-9453-D49E-F74D-2518A8D7ADFA}"/>
               </a:ext>
             </a:extLst>
           </p:cNvPr>
@@ -1472,8 +1472,8 @@
         </p:nvSpPr>
         <p:spPr>
           <a:xfrm>
-            <a:off x="502920" y="1460500"/>
-            <a:ext cx="3108960" cy="3481070"/>
+            <a:off x="838200" y="1825625"/>
+            <a:ext cx="5181600" cy="4351338"/>
           </a:xfrm>
         </p:spPr>
         <p:txBody>
@@ -1521,7 +1521,7 @@
           <p:cNvPr id="4" name="Content Placeholder 3">
             <a:extLst>
               <a:ext uri="{FF2B5EF4-FFF2-40B4-BE49-F238E27FC236}">
-                <a16:creationId xmlns:a16="http://schemas.microsoft.com/office/drawing/2014/main" id="{D4CC26A9-2BBC-D0E2-D05F-BAD6EE40DE04}"/>
+                <a16:creationId xmlns:a16="http://schemas.microsoft.com/office/drawing/2014/main" id="{4FF794A3-A155-D627-5885-F32DE87CDE54}"/>
               </a:ext>
             </a:extLst>
           </p:cNvPr>
@@ -1534,8 +1534,8 @@
         </p:nvSpPr>
         <p:spPr>
           <a:xfrm>
-            <a:off x="3703320" y="1460500"/>
-            <a:ext cx="3108960" cy="3481070"/>
+            <a:off x="6172200" y="1825625"/>
+            <a:ext cx="5181600" cy="4351338"/>
           </a:xfrm>
         </p:spPr>
         <p:txBody>
@@ -1583,7 +1583,7 @@
           <p:cNvPr id="5" name="Date Placeholder 4">
             <a:extLst>
               <a:ext uri="{FF2B5EF4-FFF2-40B4-BE49-F238E27FC236}">
-                <a16:creationId xmlns:a16="http://schemas.microsoft.com/office/drawing/2014/main" id="{E147D834-C290-E5C3-96A8-4AB625075750}"/>
+                <a16:creationId xmlns:a16="http://schemas.microsoft.com/office/drawing/2014/main" id="{113E550B-71D0-252A-2DBD-BB9B6E62D643}"/>
               </a:ext>
             </a:extLst>
           </p:cNvPr>
@@ -1599,7 +1599,7 @@
           <a:bodyPr/>
           <a:lstStyle/>
           <a:p>
-            <a:fld id="{35E6844C-3C51-4918-A9D5-3B7132835869}" type="datetimeFigureOut">
+            <a:fld id="{6E27AF6A-912D-4C46-A256-6E6A6FF02C93}" type="datetimeFigureOut">
               <a:rPr lang="en-US" smtClean="0"/>
               <a:t>8/13/2026</a:t>
             </a:fld>
@@ -1612,7 +1612,7 @@
           <p:cNvPr id="6" name="Footer Placeholder 5">
             <a:extLst>
               <a:ext uri="{FF2B5EF4-FFF2-40B4-BE49-F238E27FC236}">
-                <a16:creationId xmlns:a16="http://schemas.microsoft.com/office/drawing/2014/main" id="{2F911BB3-369B-9A01-4A42-7ADF2F685F32}"/>
+                <a16:creationId xmlns:a16="http://schemas.microsoft.com/office/drawing/2014/main" id="{4CFA4778-5F0F-7269-E9A6-0D1AAC514D2E}"/>
               </a:ext>
             </a:extLst>
           </p:cNvPr>
@@ -1637,7 +1637,7 @@
           <p:cNvPr id="7" name="Slide Number Placeholder 6">
             <a:extLst>
               <a:ext uri="{FF2B5EF4-FFF2-40B4-BE49-F238E27FC236}">
-                <a16:creationId xmlns:a16="http://schemas.microsoft.com/office/drawing/2014/main" id="{FA3BC77E-25EA-274C-A559-44FBE51391E7}"/>
+                <a16:creationId xmlns:a16="http://schemas.microsoft.com/office/drawing/2014/main" id="{4F8F5FE7-2ABD-C46F-BB25-9549E6562347}"/>
               </a:ext>
             </a:extLst>
           </p:cNvPr>
@@ -1653,7 +1653,7 @@
           <a:bodyPr/>
           <a:lstStyle/>
           <a:p>
-            <a:fld id="{F3AC3495-A25B-46F5-9D8B-F07130A6FEDC}" type="slidenum">
+            <a:fld id="{95780A41-0D26-45C0-A0CB-A6488D853006}" type="slidenum">
               <a:rPr lang="en-US" smtClean="0"/>
               <a:t>‹#›</a:t>
             </a:fld>
@@ -1664,7 +1664,7 @@
     </p:spTree>
     <p:extLst>
       <p:ext uri="{BB962C8B-B14F-4D97-AF65-F5344CB8AC3E}">
-        <p14:creationId xmlns:p14="http://schemas.microsoft.com/office/powerpoint/2010/main" val="3302834674"/>
+        <p14:creationId xmlns:p14="http://schemas.microsoft.com/office/powerpoint/2010/main" val="1518348985"/>
       </p:ext>
     </p:extLst>
   </p:cSld>
@@ -1696,7 +1696,7 @@
           <p:cNvPr id="2" name="Title 1">
             <a:extLst>
               <a:ext uri="{FF2B5EF4-FFF2-40B4-BE49-F238E27FC236}">
-                <a16:creationId xmlns:a16="http://schemas.microsoft.com/office/drawing/2014/main" id="{E58053BE-77E2-F0B2-77A6-94D318DAF831}"/>
+                <a16:creationId xmlns:a16="http://schemas.microsoft.com/office/drawing/2014/main" id="{96E06D8E-BFD1-864C-4DA2-BCD00FCC8630}"/>
               </a:ext>
             </a:extLst>
           </p:cNvPr>
@@ -1709,8 +1709,8 @@
         </p:nvSpPr>
         <p:spPr>
           <a:xfrm>
-            <a:off x="503873" y="292101"/>
-            <a:ext cx="6309360" cy="1060450"/>
+            <a:off x="839788" y="365125"/>
+            <a:ext cx="10515600" cy="1325563"/>
           </a:xfrm>
         </p:spPr>
         <p:txBody>
@@ -1729,7 +1729,7 @@
           <p:cNvPr id="3" name="Text Placeholder 2">
             <a:extLst>
               <a:ext uri="{FF2B5EF4-FFF2-40B4-BE49-F238E27FC236}">
-                <a16:creationId xmlns:a16="http://schemas.microsoft.com/office/drawing/2014/main" id="{00FC9AED-AFA6-11F5-5E98-646FA493EA1A}"/>
+                <a16:creationId xmlns:a16="http://schemas.microsoft.com/office/drawing/2014/main" id="{7A5E76DA-0DC0-F505-2C7D-F9220B652FBC}"/>
               </a:ext>
             </a:extLst>
           </p:cNvPr>
@@ -1742,8 +1742,8 @@
         </p:nvSpPr>
         <p:spPr>
           <a:xfrm>
-            <a:off x="503873" y="1344930"/>
-            <a:ext cx="3094672" cy="659130"/>
+            <a:off x="839788" y="1681163"/>
+            <a:ext cx="5157787" cy="823912"/>
           </a:xfrm>
         </p:spPr>
         <p:txBody>
@@ -1751,39 +1751,39 @@
           <a:lstStyle>
             <a:lvl1pPr marL="0" indent="0">
               <a:buNone/>
-              <a:defRPr sz="1440" b="1"/>
+              <a:defRPr sz="2400" b="1"/>
             </a:lvl1pPr>
-            <a:lvl2pPr marL="274320" indent="0">
-              <a:buNone/>
-              <a:defRPr sz="1200" b="1"/>
+            <a:lvl2pPr marL="457200" indent="0">
+              <a:buNone/>
+              <a:defRPr sz="2000" b="1"/>
             </a:lvl2pPr>
-            <a:lvl3pPr marL="548640" indent="0">
-              <a:buNone/>
-              <a:defRPr sz="1080" b="1"/>
+            <a:lvl3pPr marL="914400" indent="0">
+              <a:buNone/>
+              <a:defRPr sz="1800" b="1"/>
             </a:lvl3pPr>
-            <a:lvl4pPr marL="822960" indent="0">
-              <a:buNone/>
-              <a:defRPr sz="960" b="1"/>
+            <a:lvl4pPr marL="1371600" indent="0">
+              <a:buNone/>
+              <a:defRPr sz="1600" b="1"/>
             </a:lvl4pPr>
-            <a:lvl5pPr marL="1097280" indent="0">
-              <a:buNone/>
-              <a:defRPr sz="960" b="1"/>
+            <a:lvl5pPr marL="1828800" indent="0">
+              <a:buNone/>
+              <a:defRPr sz="1600" b="1"/>
             </a:lvl5pPr>
-            <a:lvl6pPr marL="1371600" indent="0">
-              <a:buNone/>
-              <a:defRPr sz="960" b="1"/>
+            <a:lvl6pPr marL="2286000" indent="0">
+              <a:buNone/>
+              <a:defRPr sz="1600" b="1"/>
             </a:lvl6pPr>
-            <a:lvl7pPr marL="1645920" indent="0">
-              <a:buNone/>
-              <a:defRPr sz="960" b="1"/>
+            <a:lvl7pPr marL="2743200" indent="0">
+              <a:buNone/>
+              <a:defRPr sz="1600" b="1"/>
             </a:lvl7pPr>
-            <a:lvl8pPr marL="1920240" indent="0">
-              <a:buNone/>
-              <a:defRPr sz="960" b="1"/>
+            <a:lvl8pPr marL="3200400" indent="0">
+              <a:buNone/>
+              <a:defRPr sz="1600" b="1"/>
             </a:lvl8pPr>
-            <a:lvl9pPr marL="2194560" indent="0">
-              <a:buNone/>
-              <a:defRPr sz="960" b="1"/>
+            <a:lvl9pPr marL="3657600" indent="0">
+              <a:buNone/>
+              <a:defRPr sz="1600" b="1"/>
             </a:lvl9pPr>
           </a:lstStyle>
           <a:p>
@@ -1800,7 +1800,7 @@
           <p:cNvPr id="4" name="Content Placeholder 3">
             <a:extLst>
               <a:ext uri="{FF2B5EF4-FFF2-40B4-BE49-F238E27FC236}">
-                <a16:creationId xmlns:a16="http://schemas.microsoft.com/office/drawing/2014/main" id="{EC572A52-79D6-6D9E-78BF-695D16EE27AD}"/>
+                <a16:creationId xmlns:a16="http://schemas.microsoft.com/office/drawing/2014/main" id="{836188DF-2A6D-69E1-5059-B9EAF209C132}"/>
               </a:ext>
             </a:extLst>
           </p:cNvPr>
@@ -1813,8 +1813,8 @@
         </p:nvSpPr>
         <p:spPr>
           <a:xfrm>
-            <a:off x="503873" y="2004060"/>
-            <a:ext cx="3094672" cy="2947670"/>
+            <a:off x="839788" y="2505075"/>
+            <a:ext cx="5157787" cy="3684588"/>
           </a:xfrm>
         </p:spPr>
         <p:txBody>
@@ -1862,7 +1862,7 @@
           <p:cNvPr id="5" name="Text Placeholder 4">
             <a:extLst>
               <a:ext uri="{FF2B5EF4-FFF2-40B4-BE49-F238E27FC236}">
-                <a16:creationId xmlns:a16="http://schemas.microsoft.com/office/drawing/2014/main" id="{1DFA4E52-373B-0B47-99E5-12401BC3295E}"/>
+                <a16:creationId xmlns:a16="http://schemas.microsoft.com/office/drawing/2014/main" id="{1F368ADB-B7AC-FB76-7AC1-7C21DEC06202}"/>
               </a:ext>
             </a:extLst>
           </p:cNvPr>
@@ -1875,8 +1875,8 @@
         </p:nvSpPr>
         <p:spPr>
           <a:xfrm>
-            <a:off x="3703320" y="1344930"/>
-            <a:ext cx="3109913" cy="659130"/>
+            <a:off x="6172200" y="1681163"/>
+            <a:ext cx="5183188" cy="823912"/>
           </a:xfrm>
         </p:spPr>
         <p:txBody>
@@ -1884,39 +1884,39 @@
           <a:lstStyle>
             <a:lvl1pPr marL="0" indent="0">
               <a:buNone/>
-              <a:defRPr sz="1440" b="1"/>
+              <a:defRPr sz="2400" b="1"/>
             </a:lvl1pPr>
-            <a:lvl2pPr marL="274320" indent="0">
-              <a:buNone/>
-              <a:defRPr sz="1200" b="1"/>
+            <a:lvl2pPr marL="457200" indent="0">
+              <a:buNone/>
+              <a:defRPr sz="2000" b="1"/>
             </a:lvl2pPr>
-            <a:lvl3pPr marL="548640" indent="0">
-              <a:buNone/>
-              <a:defRPr sz="1080" b="1"/>
+            <a:lvl3pPr marL="914400" indent="0">
+              <a:buNone/>
+              <a:defRPr sz="1800" b="1"/>
             </a:lvl3pPr>
-            <a:lvl4pPr marL="822960" indent="0">
-              <a:buNone/>
-              <a:defRPr sz="960" b="1"/>
+            <a:lvl4pPr marL="1371600" indent="0">
+              <a:buNone/>
+              <a:defRPr sz="1600" b="1"/>
             </a:lvl4pPr>
-            <a:lvl5pPr marL="1097280" indent="0">
-              <a:buNone/>
-              <a:defRPr sz="960" b="1"/>
+            <a:lvl5pPr marL="1828800" indent="0">
+              <a:buNone/>
+              <a:defRPr sz="1600" b="1"/>
             </a:lvl5pPr>
-            <a:lvl6pPr marL="1371600" indent="0">
-              <a:buNone/>
-              <a:defRPr sz="960" b="1"/>
+            <a:lvl6pPr marL="2286000" indent="0">
+              <a:buNone/>
+              <a:defRPr sz="1600" b="1"/>
             </a:lvl6pPr>
-            <a:lvl7pPr marL="1645920" indent="0">
-              <a:buNone/>
-              <a:defRPr sz="960" b="1"/>
+            <a:lvl7pPr marL="2743200" indent="0">
+              <a:buNone/>
+              <a:defRPr sz="1600" b="1"/>
             </a:lvl7pPr>
-            <a:lvl8pPr marL="1920240" indent="0">
-              <a:buNone/>
-              <a:defRPr sz="960" b="1"/>
+            <a:lvl8pPr marL="3200400" indent="0">
+              <a:buNone/>
+              <a:defRPr sz="1600" b="1"/>
             </a:lvl8pPr>
-            <a:lvl9pPr marL="2194560" indent="0">
-              <a:buNone/>
-              <a:defRPr sz="960" b="1"/>
+            <a:lvl9pPr marL="3657600" indent="0">
+              <a:buNone/>
+              <a:defRPr sz="1600" b="1"/>
             </a:lvl9pPr>
           </a:lstStyle>
           <a:p>
@@ -1933,7 +1933,7 @@
           <p:cNvPr id="6" name="Content Placeholder 5">
             <a:extLst>
               <a:ext uri="{FF2B5EF4-FFF2-40B4-BE49-F238E27FC236}">
-                <a16:creationId xmlns:a16="http://schemas.microsoft.com/office/drawing/2014/main" id="{A90BB8B2-6337-102B-42B6-2AD577881336}"/>
+                <a16:creationId xmlns:a16="http://schemas.microsoft.com/office/drawing/2014/main" id="{0346BB44-5F07-1AEE-2E83-ED56F983D817}"/>
               </a:ext>
             </a:extLst>
           </p:cNvPr>
@@ -1946,8 +1946,8 @@
         </p:nvSpPr>
         <p:spPr>
           <a:xfrm>
-            <a:off x="3703320" y="2004060"/>
-            <a:ext cx="3109913" cy="2947670"/>
+            <a:off x="6172200" y="2505075"/>
+            <a:ext cx="5183188" cy="3684588"/>
           </a:xfrm>
         </p:spPr>
         <p:txBody>
@@ -1995,7 +1995,7 @@
           <p:cNvPr id="7" name="Date Placeholder 6">
             <a:extLst>
               <a:ext uri="{FF2B5EF4-FFF2-40B4-BE49-F238E27FC236}">
-                <a16:creationId xmlns:a16="http://schemas.microsoft.com/office/drawing/2014/main" id="{5EE929DB-F138-DD74-BAFE-DB20A68F5D32}"/>
+                <a16:creationId xmlns:a16="http://schemas.microsoft.com/office/drawing/2014/main" id="{CBD75436-6C62-CB6C-240B-3B644827B8B8}"/>
               </a:ext>
             </a:extLst>
           </p:cNvPr>
@@ -2011,7 +2011,7 @@
           <a:bodyPr/>
           <a:lstStyle/>
           <a:p>
-            <a:fld id="{35E6844C-3C51-4918-A9D5-3B7132835869}" type="datetimeFigureOut">
+            <a:fld id="{6E27AF6A-912D-4C46-A256-6E6A6FF02C93}" type="datetimeFigureOut">
               <a:rPr lang="en-US" smtClean="0"/>
               <a:t>8/13/2026</a:t>
             </a:fld>
@@ -2024,7 +2024,7 @@
           <p:cNvPr id="8" name="Footer Placeholder 7">
             <a:extLst>
               <a:ext uri="{FF2B5EF4-FFF2-40B4-BE49-F238E27FC236}">
-                <a16:creationId xmlns:a16="http://schemas.microsoft.com/office/drawing/2014/main" id="{1EA95CE2-CF06-8D47-14F2-8123CDAAE30D}"/>
+                <a16:creationId xmlns:a16="http://schemas.microsoft.com/office/drawing/2014/main" id="{B1C05CFE-DD87-8670-5D43-5A129F2B2B19}"/>
               </a:ext>
             </a:extLst>
           </p:cNvPr>
@@ -2049,7 +2049,7 @@
           <p:cNvPr id="9" name="Slide Number Placeholder 8">
             <a:extLst>
               <a:ext uri="{FF2B5EF4-FFF2-40B4-BE49-F238E27FC236}">
-                <a16:creationId xmlns:a16="http://schemas.microsoft.com/office/drawing/2014/main" id="{3B8FA5D9-F76C-A104-268F-0B3064125E70}"/>
+                <a16:creationId xmlns:a16="http://schemas.microsoft.com/office/drawing/2014/main" id="{4B85EB94-F8FB-B4BB-AEA6-975E0FB9560C}"/>
               </a:ext>
             </a:extLst>
           </p:cNvPr>
@@ -2065,7 +2065,7 @@
           <a:bodyPr/>
           <a:lstStyle/>
           <a:p>
-            <a:fld id="{F3AC3495-A25B-46F5-9D8B-F07130A6FEDC}" type="slidenum">
+            <a:fld id="{95780A41-0D26-45C0-A0CB-A6488D853006}" type="slidenum">
               <a:rPr lang="en-US" smtClean="0"/>
               <a:t>‹#›</a:t>
             </a:fld>
@@ -2076,7 +2076,7 @@
     </p:spTree>
     <p:extLst>
       <p:ext uri="{BB962C8B-B14F-4D97-AF65-F5344CB8AC3E}">
-        <p14:creationId xmlns:p14="http://schemas.microsoft.com/office/powerpoint/2010/main" val="1669309088"/>
+        <p14:creationId xmlns:p14="http://schemas.microsoft.com/office/powerpoint/2010/main" val="1671963954"/>
       </p:ext>
     </p:extLst>
   </p:cSld>
@@ -2108,7 +2108,7 @@
           <p:cNvPr id="2" name="Title 1">
             <a:extLst>
               <a:ext uri="{FF2B5EF4-FFF2-40B4-BE49-F238E27FC236}">
-                <a16:creationId xmlns:a16="http://schemas.microsoft.com/office/drawing/2014/main" id="{0208E23B-7AC4-52F5-8402-EB18F6105B43}"/>
+                <a16:creationId xmlns:a16="http://schemas.microsoft.com/office/drawing/2014/main" id="{20481734-BBDF-0DCE-A580-86EEE494FB6C}"/>
               </a:ext>
             </a:extLst>
           </p:cNvPr>
@@ -2136,7 +2136,7 @@
           <p:cNvPr id="3" name="Date Placeholder 2">
             <a:extLst>
               <a:ext uri="{FF2B5EF4-FFF2-40B4-BE49-F238E27FC236}">
-                <a16:creationId xmlns:a16="http://schemas.microsoft.com/office/drawing/2014/main" id="{C985ECB0-3230-8C49-2E8C-FC77A92D11F5}"/>
+                <a16:creationId xmlns:a16="http://schemas.microsoft.com/office/drawing/2014/main" id="{3369D899-2C35-B463-9E05-C878A2259829}"/>
               </a:ext>
             </a:extLst>
           </p:cNvPr>
@@ -2152,7 +2152,7 @@
           <a:bodyPr/>
           <a:lstStyle/>
           <a:p>
-            <a:fld id="{35E6844C-3C51-4918-A9D5-3B7132835869}" type="datetimeFigureOut">
+            <a:fld id="{6E27AF6A-912D-4C46-A256-6E6A6FF02C93}" type="datetimeFigureOut">
               <a:rPr lang="en-US" smtClean="0"/>
               <a:t>8/13/2026</a:t>
             </a:fld>
@@ -2165,7 +2165,7 @@
           <p:cNvPr id="4" name="Footer Placeholder 3">
             <a:extLst>
               <a:ext uri="{FF2B5EF4-FFF2-40B4-BE49-F238E27FC236}">
-                <a16:creationId xmlns:a16="http://schemas.microsoft.com/office/drawing/2014/main" id="{BC3D493D-141D-9628-531C-3C299E8FC49C}"/>
+                <a16:creationId xmlns:a16="http://schemas.microsoft.com/office/drawing/2014/main" id="{94180034-8B16-A31D-896C-6650DD2CD859}"/>
               </a:ext>
             </a:extLst>
           </p:cNvPr>
@@ -2190,7 +2190,7 @@
           <p:cNvPr id="5" name="Slide Number Placeholder 4">
             <a:extLst>
               <a:ext uri="{FF2B5EF4-FFF2-40B4-BE49-F238E27FC236}">
-                <a16:creationId xmlns:a16="http://schemas.microsoft.com/office/drawing/2014/main" id="{4AEE603E-87AE-4177-7A30-199DAB36A5A1}"/>
+                <a16:creationId xmlns:a16="http://schemas.microsoft.com/office/drawing/2014/main" id="{5BA6183A-16CE-11C8-1D53-A7A31CC2EE01}"/>
               </a:ext>
             </a:extLst>
           </p:cNvPr>
@@ -2206,7 +2206,7 @@
           <a:bodyPr/>
           <a:lstStyle/>
           <a:p>
-            <a:fld id="{F3AC3495-A25B-46F5-9D8B-F07130A6FEDC}" type="slidenum">
+            <a:fld id="{95780A41-0D26-45C0-A0CB-A6488D853006}" type="slidenum">
               <a:rPr lang="en-US" smtClean="0"/>
               <a:t>‹#›</a:t>
             </a:fld>
@@ -2217,7 +2217,7 @@
     </p:spTree>
     <p:extLst>
       <p:ext uri="{BB962C8B-B14F-4D97-AF65-F5344CB8AC3E}">
-        <p14:creationId xmlns:p14="http://schemas.microsoft.com/office/powerpoint/2010/main" val="1516037318"/>
+        <p14:creationId xmlns:p14="http://schemas.microsoft.com/office/powerpoint/2010/main" val="1559888800"/>
       </p:ext>
     </p:extLst>
   </p:cSld>
@@ -2249,7 +2249,7 @@
           <p:cNvPr id="2" name="Date Placeholder 1">
             <a:extLst>
               <a:ext uri="{FF2B5EF4-FFF2-40B4-BE49-F238E27FC236}">
-                <a16:creationId xmlns:a16="http://schemas.microsoft.com/office/drawing/2014/main" id="{32E3C5A6-971D-6E6F-AE6E-688AA4400285}"/>
+                <a16:creationId xmlns:a16="http://schemas.microsoft.com/office/drawing/2014/main" id="{7FD1A965-447D-40B8-1857-B426DBF37946}"/>
               </a:ext>
             </a:extLst>
           </p:cNvPr>
@@ -2265,7 +2265,7 @@
           <a:bodyPr/>
           <a:lstStyle/>
           <a:p>
-            <a:fld id="{35E6844C-3C51-4918-A9D5-3B7132835869}" type="datetimeFigureOut">
+            <a:fld id="{6E27AF6A-912D-4C46-A256-6E6A6FF02C93}" type="datetimeFigureOut">
               <a:rPr lang="en-US" smtClean="0"/>
               <a:t>8/13/2026</a:t>
             </a:fld>
@@ -2278,7 +2278,7 @@
           <p:cNvPr id="3" name="Footer Placeholder 2">
             <a:extLst>
               <a:ext uri="{FF2B5EF4-FFF2-40B4-BE49-F238E27FC236}">
-                <a16:creationId xmlns:a16="http://schemas.microsoft.com/office/drawing/2014/main" id="{71995070-99F7-DF50-4118-030D9E9276F0}"/>
+                <a16:creationId xmlns:a16="http://schemas.microsoft.com/office/drawing/2014/main" id="{042A0477-255A-09D6-5AD3-14364D12DFCD}"/>
               </a:ext>
             </a:extLst>
           </p:cNvPr>
@@ -2303,7 +2303,7 @@
           <p:cNvPr id="4" name="Slide Number Placeholder 3">
             <a:extLst>
               <a:ext uri="{FF2B5EF4-FFF2-40B4-BE49-F238E27FC236}">
-                <a16:creationId xmlns:a16="http://schemas.microsoft.com/office/drawing/2014/main" id="{ADDD0DB8-D962-38B7-A560-3D9092ACB618}"/>
+                <a16:creationId xmlns:a16="http://schemas.microsoft.com/office/drawing/2014/main" id="{0FCB355A-BA5D-5F8F-0023-9681E64FF461}"/>
               </a:ext>
             </a:extLst>
           </p:cNvPr>
@@ -2319,7 +2319,7 @@
           <a:bodyPr/>
           <a:lstStyle/>
           <a:p>
-            <a:fld id="{F3AC3495-A25B-46F5-9D8B-F07130A6FEDC}" type="slidenum">
+            <a:fld id="{95780A41-0D26-45C0-A0CB-A6488D853006}" type="slidenum">
               <a:rPr lang="en-US" smtClean="0"/>
               <a:t>‹#›</a:t>
             </a:fld>
@@ -2330,7 +2330,7 @@
     </p:spTree>
     <p:extLst>
       <p:ext uri="{BB962C8B-B14F-4D97-AF65-F5344CB8AC3E}">
-        <p14:creationId xmlns:p14="http://schemas.microsoft.com/office/powerpoint/2010/main" val="2869677319"/>
+        <p14:creationId xmlns:p14="http://schemas.microsoft.com/office/powerpoint/2010/main" val="1727073745"/>
       </p:ext>
     </p:extLst>
   </p:cSld>
@@ -2362,7 +2362,7 @@
           <p:cNvPr id="2" name="Title 1">
             <a:extLst>
               <a:ext uri="{FF2B5EF4-FFF2-40B4-BE49-F238E27FC236}">
-                <a16:creationId xmlns:a16="http://schemas.microsoft.com/office/drawing/2014/main" id="{01985426-5FCC-91B5-5C63-4A21F3FB3B58}"/>
+                <a16:creationId xmlns:a16="http://schemas.microsoft.com/office/drawing/2014/main" id="{CEE95179-E97E-9498-7AC4-40707177059C}"/>
               </a:ext>
             </a:extLst>
           </p:cNvPr>
@@ -2375,15 +2375,15 @@
         </p:nvSpPr>
         <p:spPr>
           <a:xfrm>
-            <a:off x="503873" y="365760"/>
-            <a:ext cx="2359342" cy="1280160"/>
+            <a:off x="839788" y="457200"/>
+            <a:ext cx="3932237" cy="1600200"/>
           </a:xfrm>
         </p:spPr>
         <p:txBody>
           <a:bodyPr anchor="b"/>
           <a:lstStyle>
             <a:lvl1pPr>
-              <a:defRPr sz="1920"/>
+              <a:defRPr sz="3200"/>
             </a:lvl1pPr>
           </a:lstStyle>
           <a:p>
@@ -2399,7 +2399,7 @@
           <p:cNvPr id="3" name="Content Placeholder 2">
             <a:extLst>
               <a:ext uri="{FF2B5EF4-FFF2-40B4-BE49-F238E27FC236}">
-                <a16:creationId xmlns:a16="http://schemas.microsoft.com/office/drawing/2014/main" id="{C4F70347-9CDA-6023-0517-D6B498001C38}"/>
+                <a16:creationId xmlns:a16="http://schemas.microsoft.com/office/drawing/2014/main" id="{D2B5B42B-3C78-3358-C81D-93CB7ABC1EC2}"/>
               </a:ext>
             </a:extLst>
           </p:cNvPr>
@@ -2412,39 +2412,39 @@
         </p:nvSpPr>
         <p:spPr>
           <a:xfrm>
-            <a:off x="3109913" y="789940"/>
-            <a:ext cx="3703320" cy="3898900"/>
+            <a:off x="5183188" y="987425"/>
+            <a:ext cx="6172200" cy="4873625"/>
           </a:xfrm>
         </p:spPr>
         <p:txBody>
           <a:bodyPr/>
           <a:lstStyle>
             <a:lvl1pPr>
-              <a:defRPr sz="1920"/>
+              <a:defRPr sz="3200"/>
             </a:lvl1pPr>
             <a:lvl2pPr>
-              <a:defRPr sz="1680"/>
+              <a:defRPr sz="2800"/>
             </a:lvl2pPr>
             <a:lvl3pPr>
-              <a:defRPr sz="1440"/>
+              <a:defRPr sz="2400"/>
             </a:lvl3pPr>
             <a:lvl4pPr>
-              <a:defRPr sz="1200"/>
+              <a:defRPr sz="2000"/>
             </a:lvl4pPr>
             <a:lvl5pPr>
-              <a:defRPr sz="1200"/>
+              <a:defRPr sz="2000"/>
             </a:lvl5pPr>
             <a:lvl6pPr>
-              <a:defRPr sz="1200"/>
+              <a:defRPr sz="2000"/>
             </a:lvl6pPr>
             <a:lvl7pPr>
-              <a:defRPr sz="1200"/>
+              <a:defRPr sz="2000"/>
             </a:lvl7pPr>
             <a:lvl8pPr>
-              <a:defRPr sz="1200"/>
+              <a:defRPr sz="2000"/>
             </a:lvl8pPr>
             <a:lvl9pPr>
-              <a:defRPr sz="1200"/>
+              <a:defRPr sz="2000"/>
             </a:lvl9pPr>
           </a:lstStyle>
           <a:p>
@@ -2489,7 +2489,7 @@
           <p:cNvPr id="4" name="Text Placeholder 3">
             <a:extLst>
               <a:ext uri="{FF2B5EF4-FFF2-40B4-BE49-F238E27FC236}">
-                <a16:creationId xmlns:a16="http://schemas.microsoft.com/office/drawing/2014/main" id="{6516958F-AB21-5E08-FB7E-1C487E0487B7}"/>
+                <a16:creationId xmlns:a16="http://schemas.microsoft.com/office/drawing/2014/main" id="{AD862555-61AA-4614-E9F9-677ED3CEABEB}"/>
               </a:ext>
             </a:extLst>
           </p:cNvPr>
@@ -2502,8 +2502,8 @@
         </p:nvSpPr>
         <p:spPr>
           <a:xfrm>
-            <a:off x="503873" y="1645920"/>
-            <a:ext cx="2359342" cy="3049270"/>
+            <a:off x="839788" y="2057400"/>
+            <a:ext cx="3932237" cy="3811588"/>
           </a:xfrm>
         </p:spPr>
         <p:txBody>
@@ -2511,39 +2511,39 @@
           <a:lstStyle>
             <a:lvl1pPr marL="0" indent="0">
               <a:buNone/>
-              <a:defRPr sz="960"/>
+              <a:defRPr sz="1600"/>
             </a:lvl1pPr>
-            <a:lvl2pPr marL="274320" indent="0">
-              <a:buNone/>
-              <a:defRPr sz="840"/>
+            <a:lvl2pPr marL="457200" indent="0">
+              <a:buNone/>
+              <a:defRPr sz="1400"/>
             </a:lvl2pPr>
-            <a:lvl3pPr marL="548640" indent="0">
-              <a:buNone/>
-              <a:defRPr sz="720"/>
+            <a:lvl3pPr marL="914400" indent="0">
+              <a:buNone/>
+              <a:defRPr sz="1200"/>
             </a:lvl3pPr>
-            <a:lvl4pPr marL="822960" indent="0">
-              <a:buNone/>
-              <a:defRPr sz="600"/>
+            <a:lvl4pPr marL="1371600" indent="0">
+              <a:buNone/>
+              <a:defRPr sz="1000"/>
             </a:lvl4pPr>
-            <a:lvl5pPr marL="1097280" indent="0">
-              <a:buNone/>
-              <a:defRPr sz="600"/>
+            <a:lvl5pPr marL="1828800" indent="0">
+              <a:buNone/>
+              <a:defRPr sz="1000"/>
             </a:lvl5pPr>
-            <a:lvl6pPr marL="1371600" indent="0">
-              <a:buNone/>
-              <a:defRPr sz="600"/>
+            <a:lvl6pPr marL="2286000" indent="0">
+              <a:buNone/>
+              <a:defRPr sz="1000"/>
             </a:lvl6pPr>
-            <a:lvl7pPr marL="1645920" indent="0">
-              <a:buNone/>
-              <a:defRPr sz="600"/>
+            <a:lvl7pPr marL="2743200" indent="0">
+              <a:buNone/>
+              <a:defRPr sz="1000"/>
             </a:lvl7pPr>
-            <a:lvl8pPr marL="1920240" indent="0">
-              <a:buNone/>
-              <a:defRPr sz="600"/>
+            <a:lvl8pPr marL="3200400" indent="0">
+              <a:buNone/>
+              <a:defRPr sz="1000"/>
             </a:lvl8pPr>
-            <a:lvl9pPr marL="2194560" indent="0">
-              <a:buNone/>
-              <a:defRPr sz="600"/>
+            <a:lvl9pPr marL="3657600" indent="0">
+              <a:buNone/>
+              <a:defRPr sz="1000"/>
             </a:lvl9pPr>
           </a:lstStyle>
           <a:p>
@@ -2560,7 +2560,7 @@
           <p:cNvPr id="5" name="Date Placeholder 4">
             <a:extLst>
               <a:ext uri="{FF2B5EF4-FFF2-40B4-BE49-F238E27FC236}">
-                <a16:creationId xmlns:a16="http://schemas.microsoft.com/office/drawing/2014/main" id="{0C96FA92-0232-7326-D5BE-E4D589CA06DA}"/>
+                <a16:creationId xmlns:a16="http://schemas.microsoft.com/office/drawing/2014/main" id="{3BC60337-DB72-7255-3F3D-370CDFF69FF1}"/>
               </a:ext>
             </a:extLst>
           </p:cNvPr>
@@ -2576,7 +2576,7 @@
           <a:bodyPr/>
           <a:lstStyle/>
           <a:p>
-            <a:fld id="{35E6844C-3C51-4918-A9D5-3B7132835869}" type="datetimeFigureOut">
+            <a:fld id="{6E27AF6A-912D-4C46-A256-6E6A6FF02C93}" type="datetimeFigureOut">
               <a:rPr lang="en-US" smtClean="0"/>
               <a:t>8/13/2026</a:t>
             </a:fld>
@@ -2589,7 +2589,7 @@
           <p:cNvPr id="6" name="Footer Placeholder 5">
             <a:extLst>
               <a:ext uri="{FF2B5EF4-FFF2-40B4-BE49-F238E27FC236}">
-                <a16:creationId xmlns:a16="http://schemas.microsoft.com/office/drawing/2014/main" id="{34B6BDE2-A8BF-85B2-D993-66EA53EB3CE1}"/>
+                <a16:creationId xmlns:a16="http://schemas.microsoft.com/office/drawing/2014/main" id="{2DAFF475-FC33-7E7F-E90A-4FABBDA266CE}"/>
               </a:ext>
             </a:extLst>
           </p:cNvPr>
@@ -2614,7 +2614,7 @@
           <p:cNvPr id="7" name="Slide Number Placeholder 6">
             <a:extLst>
               <a:ext uri="{FF2B5EF4-FFF2-40B4-BE49-F238E27FC236}">
-                <a16:creationId xmlns:a16="http://schemas.microsoft.com/office/drawing/2014/main" id="{A98469E1-C796-B361-8E9A-6C4410915930}"/>
+                <a16:creationId xmlns:a16="http://schemas.microsoft.com/office/drawing/2014/main" id="{16511AC6-04F3-D354-00FE-B12FAFF03D5D}"/>
               </a:ext>
             </a:extLst>
           </p:cNvPr>
@@ -2630,7 +2630,7 @@
           <a:bodyPr/>
           <a:lstStyle/>
           <a:p>
-            <a:fld id="{F3AC3495-A25B-46F5-9D8B-F07130A6FEDC}" type="slidenum">
+            <a:fld id="{95780A41-0D26-45C0-A0CB-A6488D853006}" type="slidenum">
               <a:rPr lang="en-US" smtClean="0"/>
               <a:t>‹#›</a:t>
             </a:fld>
@@ -2641,7 +2641,7 @@
     </p:spTree>
     <p:extLst>
       <p:ext uri="{BB962C8B-B14F-4D97-AF65-F5344CB8AC3E}">
-        <p14:creationId xmlns:p14="http://schemas.microsoft.com/office/powerpoint/2010/main" val="1392218454"/>
+        <p14:creationId xmlns:p14="http://schemas.microsoft.com/office/powerpoint/2010/main" val="751171404"/>
       </p:ext>
     </p:extLst>
   </p:cSld>
@@ -2673,7 +2673,7 @@
           <p:cNvPr id="2" name="Title 1">
             <a:extLst>
               <a:ext uri="{FF2B5EF4-FFF2-40B4-BE49-F238E27FC236}">
-                <a16:creationId xmlns:a16="http://schemas.microsoft.com/office/drawing/2014/main" id="{D448638D-484C-5DF7-70AD-929D823A04EF}"/>
+                <a16:creationId xmlns:a16="http://schemas.microsoft.com/office/drawing/2014/main" id="{8FD3B705-756C-6A93-9E9C-E7DDF00B0C25}"/>
               </a:ext>
             </a:extLst>
           </p:cNvPr>
@@ -2686,15 +2686,15 @@
         </p:nvSpPr>
         <p:spPr>
           <a:xfrm>
-            <a:off x="503873" y="365760"/>
-            <a:ext cx="2359342" cy="1280160"/>
+            <a:off x="839788" y="457200"/>
+            <a:ext cx="3932237" cy="1600200"/>
           </a:xfrm>
         </p:spPr>
         <p:txBody>
           <a:bodyPr anchor="b"/>
           <a:lstStyle>
             <a:lvl1pPr>
-              <a:defRPr sz="1920"/>
+              <a:defRPr sz="3200"/>
             </a:lvl1pPr>
           </a:lstStyle>
           <a:p>
@@ -2710,7 +2710,7 @@
           <p:cNvPr id="3" name="Picture Placeholder 2">
             <a:extLst>
               <a:ext uri="{FF2B5EF4-FFF2-40B4-BE49-F238E27FC236}">
-                <a16:creationId xmlns:a16="http://schemas.microsoft.com/office/drawing/2014/main" id="{0F9F0652-49ED-9E0B-8494-CC2D5C1E4D18}"/>
+                <a16:creationId xmlns:a16="http://schemas.microsoft.com/office/drawing/2014/main" id="{8D499C7E-ED1E-C36C-2525-60DA7FA02E65}"/>
               </a:ext>
             </a:extLst>
           </p:cNvPr>
@@ -2723,8 +2723,8 @@
         </p:nvSpPr>
         <p:spPr>
           <a:xfrm>
-            <a:off x="3109913" y="789940"/>
-            <a:ext cx="3703320" cy="3898900"/>
+            <a:off x="5183188" y="987425"/>
+            <a:ext cx="6172200" cy="4873625"/>
           </a:xfrm>
         </p:spPr>
         <p:txBody>
@@ -2732,39 +2732,39 @@
           <a:lstStyle>
             <a:lvl1pPr marL="0" indent="0">
               <a:buNone/>
-              <a:defRPr sz="1920"/>
+              <a:defRPr sz="3200"/>
             </a:lvl1pPr>
-            <a:lvl2pPr marL="274320" indent="0">
-              <a:buNone/>
-              <a:defRPr sz="1680"/>
+            <a:lvl2pPr marL="457200" indent="0">
+              <a:buNone/>
+              <a:defRPr sz="2800"/>
             </a:lvl2pPr>
-            <a:lvl3pPr marL="548640" indent="0">
-              <a:buNone/>
-              <a:defRPr sz="1440"/>
+            <a:lvl3pPr marL="914400" indent="0">
+              <a:buNone/>
+              <a:defRPr sz="2400"/>
             </a:lvl3pPr>
-            <a:lvl4pPr marL="822960" indent="0">
-              <a:buNone/>
-              <a:defRPr sz="1200"/>
+            <a:lvl4pPr marL="1371600" indent="0">
+              <a:buNone/>
+              <a:defRPr sz="2000"/>
             </a:lvl4pPr>
-            <a:lvl5pPr marL="1097280" indent="0">
-              <a:buNone/>
-              <a:defRPr sz="1200"/>
+            <a:lvl5pPr marL="1828800" indent="0">
+              <a:buNone/>
+              <a:defRPr sz="2000"/>
             </a:lvl5pPr>
-            <a:lvl6pPr marL="1371600" indent="0">
-              <a:buNone/>
-              <a:defRPr sz="1200"/>
+            <a:lvl6pPr marL="2286000" indent="0">
+              <a:buNone/>
+              <a:defRPr sz="2000"/>
             </a:lvl6pPr>
-            <a:lvl7pPr marL="1645920" indent="0">
-              <a:buNone/>
-              <a:defRPr sz="1200"/>
+            <a:lvl7pPr marL="2743200" indent="0">
+              <a:buNone/>
+              <a:defRPr sz="2000"/>
             </a:lvl7pPr>
-            <a:lvl8pPr marL="1920240" indent="0">
-              <a:buNone/>
-              <a:defRPr sz="1200"/>
+            <a:lvl8pPr marL="3200400" indent="0">
+              <a:buNone/>
+              <a:defRPr sz="2000"/>
             </a:lvl8pPr>
-            <a:lvl9pPr marL="2194560" indent="0">
-              <a:buNone/>
-              <a:defRPr sz="1200"/>
+            <a:lvl9pPr marL="3657600" indent="0">
+              <a:buNone/>
+              <a:defRPr sz="2000"/>
             </a:lvl9pPr>
           </a:lstStyle>
           <a:p>
@@ -2777,7 +2777,7 @@
           <p:cNvPr id="4" name="Text Placeholder 3">
             <a:extLst>
               <a:ext uri="{FF2B5EF4-FFF2-40B4-BE49-F238E27FC236}">
-                <a16:creationId xmlns:a16="http://schemas.microsoft.com/office/drawing/2014/main" id="{61E683AE-6BB3-1086-6664-BA17E7C99BA3}"/>
+                <a16:creationId xmlns:a16="http://schemas.microsoft.com/office/drawing/2014/main" id="{276AF68E-6A3A-7AC8-4BB1-A1F2EECC96FB}"/>
               </a:ext>
             </a:extLst>
           </p:cNvPr>
@@ -2790,8 +2790,8 @@
         </p:nvSpPr>
         <p:spPr>
           <a:xfrm>
-            <a:off x="503873" y="1645920"/>
-            <a:ext cx="2359342" cy="3049270"/>
+            <a:off x="839788" y="2057400"/>
+            <a:ext cx="3932237" cy="3811588"/>
           </a:xfrm>
         </p:spPr>
         <p:txBody>
@@ -2799,39 +2799,39 @@
           <a:lstStyle>
             <a:lvl1pPr marL="0" indent="0">
               <a:buNone/>
-              <a:defRPr sz="960"/>
+              <a:defRPr sz="1600"/>
             </a:lvl1pPr>
-            <a:lvl2pPr marL="274320" indent="0">
-              <a:buNone/>
-              <a:defRPr sz="840"/>
+            <a:lvl2pPr marL="457200" indent="0">
+              <a:buNone/>
+              <a:defRPr sz="1400"/>
             </a:lvl2pPr>
-            <a:lvl3pPr marL="548640" indent="0">
-              <a:buNone/>
-              <a:defRPr sz="720"/>
+            <a:lvl3pPr marL="914400" indent="0">
+              <a:buNone/>
+              <a:defRPr sz="1200"/>
             </a:lvl3pPr>
-            <a:lvl4pPr marL="822960" indent="0">
-              <a:buNone/>
-              <a:defRPr sz="600"/>
+            <a:lvl4pPr marL="1371600" indent="0">
+              <a:buNone/>
+              <a:defRPr sz="1000"/>
             </a:lvl4pPr>
-            <a:lvl5pPr marL="1097280" indent="0">
-              <a:buNone/>
-              <a:defRPr sz="600"/>
+            <a:lvl5pPr marL="1828800" indent="0">
+              <a:buNone/>
+              <a:defRPr sz="1000"/>
             </a:lvl5pPr>
-            <a:lvl6pPr marL="1371600" indent="0">
-              <a:buNone/>
-              <a:defRPr sz="600"/>
+            <a:lvl6pPr marL="2286000" indent="0">
+              <a:buNone/>
+              <a:defRPr sz="1000"/>
             </a:lvl6pPr>
-            <a:lvl7pPr marL="1645920" indent="0">
-              <a:buNone/>
-              <a:defRPr sz="600"/>
+            <a:lvl7pPr marL="2743200" indent="0">
+              <a:buNone/>
+              <a:defRPr sz="1000"/>
             </a:lvl7pPr>
-            <a:lvl8pPr marL="1920240" indent="0">
-              <a:buNone/>
-              <a:defRPr sz="600"/>
+            <a:lvl8pPr marL="3200400" indent="0">
+              <a:buNone/>
+              <a:defRPr sz="1000"/>
             </a:lvl8pPr>
-            <a:lvl9pPr marL="2194560" indent="0">
-              <a:buNone/>
-              <a:defRPr sz="600"/>
+            <a:lvl9pPr marL="3657600" indent="0">
+              <a:buNone/>
+              <a:defRPr sz="1000"/>
             </a:lvl9pPr>
           </a:lstStyle>
           <a:p>
@@ -2848,7 +2848,7 @@
           <p:cNvPr id="5" name="Date Placeholder 4">
             <a:extLst>
               <a:ext uri="{FF2B5EF4-FFF2-40B4-BE49-F238E27FC236}">
-                <a16:creationId xmlns:a16="http://schemas.microsoft.com/office/drawing/2014/main" id="{DF31A73C-50F2-DD33-A998-07B9A3C90AAA}"/>
+                <a16:creationId xmlns:a16="http://schemas.microsoft.com/office/drawing/2014/main" id="{CA6402F5-3DB4-8D52-AA9E-573FF6AD5536}"/>
               </a:ext>
             </a:extLst>
           </p:cNvPr>
@@ -2864,7 +2864,7 @@
           <a:bodyPr/>
           <a:lstStyle/>
           <a:p>
-            <a:fld id="{35E6844C-3C51-4918-A9D5-3B7132835869}" type="datetimeFigureOut">
+            <a:fld id="{6E27AF6A-912D-4C46-A256-6E6A6FF02C93}" type="datetimeFigureOut">
               <a:rPr lang="en-US" smtClean="0"/>
               <a:t>8/13/2026</a:t>
             </a:fld>
@@ -2877,7 +2877,7 @@
           <p:cNvPr id="6" name="Footer Placeholder 5">
             <a:extLst>
               <a:ext uri="{FF2B5EF4-FFF2-40B4-BE49-F238E27FC236}">
-                <a16:creationId xmlns:a16="http://schemas.microsoft.com/office/drawing/2014/main" id="{D01889DC-27B2-8ABB-7F68-931AEBD87A3C}"/>
+                <a16:creationId xmlns:a16="http://schemas.microsoft.com/office/drawing/2014/main" id="{6E96B7DE-E19C-E844-FF16-2347E0D42A54}"/>
               </a:ext>
             </a:extLst>
           </p:cNvPr>
@@ -2902,7 +2902,7 @@
           <p:cNvPr id="7" name="Slide Number Placeholder 6">
             <a:extLst>
               <a:ext uri="{FF2B5EF4-FFF2-40B4-BE49-F238E27FC236}">
-                <a16:creationId xmlns:a16="http://schemas.microsoft.com/office/drawing/2014/main" id="{28C71CA4-E27C-2443-4A45-56578DFD550E}"/>
+                <a16:creationId xmlns:a16="http://schemas.microsoft.com/office/drawing/2014/main" id="{A6FE7440-05B4-6BFB-C5BC-2790D7543DF4}"/>
               </a:ext>
             </a:extLst>
           </p:cNvPr>
@@ -2918,7 +2918,7 @@
           <a:bodyPr/>
           <a:lstStyle/>
           <a:p>
-            <a:fld id="{F3AC3495-A25B-46F5-9D8B-F07130A6FEDC}" type="slidenum">
+            <a:fld id="{95780A41-0D26-45C0-A0CB-A6488D853006}" type="slidenum">
               <a:rPr lang="en-US" smtClean="0"/>
               <a:t>‹#›</a:t>
             </a:fld>
@@ -2929,7 +2929,7 @@
     </p:spTree>
     <p:extLst>
       <p:ext uri="{BB962C8B-B14F-4D97-AF65-F5344CB8AC3E}">
-        <p14:creationId xmlns:p14="http://schemas.microsoft.com/office/powerpoint/2010/main" val="307977563"/>
+        <p14:creationId xmlns:p14="http://schemas.microsoft.com/office/powerpoint/2010/main" val="1964718107"/>
       </p:ext>
     </p:extLst>
   </p:cSld>
@@ -2966,7 +2966,7 @@
           <p:cNvPr id="2" name="Title Placeholder 1">
             <a:extLst>
               <a:ext uri="{FF2B5EF4-FFF2-40B4-BE49-F238E27FC236}">
-                <a16:creationId xmlns:a16="http://schemas.microsoft.com/office/drawing/2014/main" id="{FE2D2A6B-3DB4-9AE7-6FC3-B166EED98198}"/>
+                <a16:creationId xmlns:a16="http://schemas.microsoft.com/office/drawing/2014/main" id="{22AB4B17-8E5F-7C01-A916-2B0E4B9837A4}"/>
               </a:ext>
             </a:extLst>
           </p:cNvPr>
@@ -2979,8 +2979,8 @@
         </p:nvSpPr>
         <p:spPr>
           <a:xfrm>
-            <a:off x="502920" y="292101"/>
-            <a:ext cx="6309360" cy="1060450"/>
+            <a:off x="838200" y="365125"/>
+            <a:ext cx="10515600" cy="1325563"/>
           </a:xfrm>
           <a:prstGeom prst="rect">
             <a:avLst/>
@@ -3004,7 +3004,7 @@
           <p:cNvPr id="3" name="Text Placeholder 2">
             <a:extLst>
               <a:ext uri="{FF2B5EF4-FFF2-40B4-BE49-F238E27FC236}">
-                <a16:creationId xmlns:a16="http://schemas.microsoft.com/office/drawing/2014/main" id="{427CF68F-A008-8870-7589-2DF11FC4DC76}"/>
+                <a16:creationId xmlns:a16="http://schemas.microsoft.com/office/drawing/2014/main" id="{14BC88CA-1DE0-AE51-FEEF-D9640F7562D0}"/>
               </a:ext>
             </a:extLst>
           </p:cNvPr>
@@ -3017,8 +3017,8 @@
         </p:nvSpPr>
         <p:spPr>
           <a:xfrm>
-            <a:off x="502920" y="1460500"/>
-            <a:ext cx="6309360" cy="3481070"/>
+            <a:off x="838200" y="1825625"/>
+            <a:ext cx="10515600" cy="4351338"/>
           </a:xfrm>
           <a:prstGeom prst="rect">
             <a:avLst/>
@@ -3071,7 +3071,7 @@
           <p:cNvPr id="4" name="Date Placeholder 3">
             <a:extLst>
               <a:ext uri="{FF2B5EF4-FFF2-40B4-BE49-F238E27FC236}">
-                <a16:creationId xmlns:a16="http://schemas.microsoft.com/office/drawing/2014/main" id="{AD7BB082-DAFC-8D4E-2ACA-19B3C5ED8960}"/>
+                <a16:creationId xmlns:a16="http://schemas.microsoft.com/office/drawing/2014/main" id="{0CBB5290-E74C-FF9D-99A4-FB8BB1D0079C}"/>
               </a:ext>
             </a:extLst>
           </p:cNvPr>
@@ -3084,8 +3084,8 @@
         </p:nvSpPr>
         <p:spPr>
           <a:xfrm>
-            <a:off x="502920" y="5085080"/>
-            <a:ext cx="1645920" cy="292100"/>
+            <a:off x="838200" y="6356350"/>
+            <a:ext cx="2743200" cy="365125"/>
           </a:xfrm>
           <a:prstGeom prst="rect">
             <a:avLst/>
@@ -3095,7 +3095,7 @@
           <a:bodyPr vert="horz" lIns="91440" tIns="45720" rIns="91440" bIns="45720" rtlCol="0" anchor="ctr"/>
           <a:lstStyle>
             <a:lvl1pPr algn="l">
-              <a:defRPr sz="720">
+              <a:defRPr sz="1200">
                 <a:solidFill>
                   <a:schemeClr val="tx1">
                     <a:tint val="82000"/>
@@ -3105,7 +3105,7 @@
             </a:lvl1pPr>
           </a:lstStyle>
           <a:p>
-            <a:fld id="{35E6844C-3C51-4918-A9D5-3B7132835869}" type="datetimeFigureOut">
+            <a:fld id="{6E27AF6A-912D-4C46-A256-6E6A6FF02C93}" type="datetimeFigureOut">
               <a:rPr lang="en-US" smtClean="0"/>
               <a:t>8/13/2026</a:t>
             </a:fld>
@@ -3118,7 +3118,7 @@
           <p:cNvPr id="5" name="Footer Placeholder 4">
             <a:extLst>
               <a:ext uri="{FF2B5EF4-FFF2-40B4-BE49-F238E27FC236}">
-                <a16:creationId xmlns:a16="http://schemas.microsoft.com/office/drawing/2014/main" id="{6BA1D760-B482-6E94-C8D1-E00482674857}"/>
+                <a16:creationId xmlns:a16="http://schemas.microsoft.com/office/drawing/2014/main" id="{50879266-F5BF-D841-D053-489DA5B8FC61}"/>
               </a:ext>
             </a:extLst>
           </p:cNvPr>
@@ -3131,8 +3131,8 @@
         </p:nvSpPr>
         <p:spPr>
           <a:xfrm>
-            <a:off x="2423160" y="5085080"/>
-            <a:ext cx="2468880" cy="292100"/>
+            <a:off x="4038600" y="6356350"/>
+            <a:ext cx="4114800" cy="365125"/>
           </a:xfrm>
           <a:prstGeom prst="rect">
             <a:avLst/>
@@ -3142,7 +3142,7 @@
           <a:bodyPr vert="horz" lIns="91440" tIns="45720" rIns="91440" bIns="45720" rtlCol="0" anchor="ctr"/>
           <a:lstStyle>
             <a:lvl1pPr algn="ctr">
-              <a:defRPr sz="720">
+              <a:defRPr sz="1200">
                 <a:solidFill>
                   <a:schemeClr val="tx1">
                     <a:tint val="82000"/>
@@ -3161,7 +3161,7 @@
           <p:cNvPr id="6" name="Slide Number Placeholder 5">
             <a:extLst>
               <a:ext uri="{FF2B5EF4-FFF2-40B4-BE49-F238E27FC236}">
-                <a16:creationId xmlns:a16="http://schemas.microsoft.com/office/drawing/2014/main" id="{C430F197-CE65-8C22-1AB8-D0C8423F62B0}"/>
+                <a16:creationId xmlns:a16="http://schemas.microsoft.com/office/drawing/2014/main" id="{07D52AC9-5007-E430-0D9A-BC9E8096A562}"/>
               </a:ext>
             </a:extLst>
           </p:cNvPr>
@@ -3174,8 +3174,8 @@
         </p:nvSpPr>
         <p:spPr>
           <a:xfrm>
-            <a:off x="5166360" y="5085080"/>
-            <a:ext cx="1645920" cy="292100"/>
+            <a:off x="8610600" y="6356350"/>
+            <a:ext cx="2743200" cy="365125"/>
           </a:xfrm>
           <a:prstGeom prst="rect">
             <a:avLst/>
@@ -3185,7 +3185,7 @@
           <a:bodyPr vert="horz" lIns="91440" tIns="45720" rIns="91440" bIns="45720" rtlCol="0" anchor="ctr"/>
           <a:lstStyle>
             <a:lvl1pPr algn="r">
-              <a:defRPr sz="720">
+              <a:defRPr sz="1200">
                 <a:solidFill>
                   <a:schemeClr val="tx1">
                     <a:tint val="82000"/>
@@ -3195,7 +3195,7 @@
             </a:lvl1pPr>
           </a:lstStyle>
           <a:p>
-            <a:fld id="{F3AC3495-A25B-46F5-9D8B-F07130A6FEDC}" type="slidenum">
+            <a:fld id="{95780A41-0D26-45C0-A0CB-A6488D853006}" type="slidenum">
               <a:rPr lang="en-US" smtClean="0"/>
               <a:t>‹#›</a:t>
             </a:fld>
@@ -3206,7 +3206,7 @@
     </p:spTree>
     <p:extLst>
       <p:ext uri="{BB962C8B-B14F-4D97-AF65-F5344CB8AC3E}">
-        <p14:creationId xmlns:p14="http://schemas.microsoft.com/office/powerpoint/2010/main" val="180142053"/>
+        <p14:creationId xmlns:p14="http://schemas.microsoft.com/office/powerpoint/2010/main" val="3164086480"/>
       </p:ext>
     </p:extLst>
   </p:cSld>
@@ -3227,7 +3227,7 @@
   </p:sldLayoutIdLst>
   <p:txStyles>
     <p:titleStyle>
-      <a:lvl1pPr algn="l" defTabSz="548640" rtl="0" eaLnBrk="1" latinLnBrk="0" hangingPunct="1">
+      <a:lvl1pPr algn="l" defTabSz="914400" rtl="0" eaLnBrk="1" latinLnBrk="0" hangingPunct="1">
         <a:lnSpc>
           <a:spcPct val="90000"/>
         </a:lnSpc>
@@ -3235,7 +3235,7 @@
           <a:spcPct val="0"/>
         </a:spcBef>
         <a:buNone/>
-        <a:defRPr sz="2640" kern="1200">
+        <a:defRPr sz="4400" kern="1200">
           <a:solidFill>
             <a:schemeClr val="tx1"/>
           </a:solidFill>
@@ -3246,16 +3246,16 @@
       </a:lvl1pPr>
     </p:titleStyle>
     <p:bodyStyle>
-      <a:lvl1pPr marL="137160" indent="-137160" algn="l" defTabSz="548640" rtl="0" eaLnBrk="1" latinLnBrk="0" hangingPunct="1">
+      <a:lvl1pPr marL="228600" indent="-228600" algn="l" defTabSz="914400" rtl="0" eaLnBrk="1" latinLnBrk="0" hangingPunct="1">
         <a:lnSpc>
           <a:spcPct val="90000"/>
         </a:lnSpc>
         <a:spcBef>
-          <a:spcPts val="600"/>
+          <a:spcPts val="1000"/>
         </a:spcBef>
         <a:buFont typeface="Arial" panose="020B0604020202020204" pitchFamily="34" charset="0"/>
         <a:buChar char="•"/>
-        <a:defRPr sz="1680" kern="1200">
+        <a:defRPr sz="2800" kern="1200">
           <a:solidFill>
             <a:schemeClr val="tx1"/>
           </a:solidFill>
@@ -3264,16 +3264,16 @@
           <a:cs typeface="+mn-cs"/>
         </a:defRPr>
       </a:lvl1pPr>
-      <a:lvl2pPr marL="411480" indent="-137160" algn="l" defTabSz="548640" rtl="0" eaLnBrk="1" latinLnBrk="0" hangingPunct="1">
+      <a:lvl2pPr marL="685800" indent="-228600" algn="l" defTabSz="914400" rtl="0" eaLnBrk="1" latinLnBrk="0" hangingPunct="1">
         <a:lnSpc>
           <a:spcPct val="90000"/>
         </a:lnSpc>
         <a:spcBef>
-          <a:spcPts val="300"/>
+          <a:spcPts val="500"/>
         </a:spcBef>
         <a:buFont typeface="Arial" panose="020B0604020202020204" pitchFamily="34" charset="0"/>
         <a:buChar char="•"/>
-        <a:defRPr sz="1440" kern="1200">
+        <a:defRPr sz="2400" kern="1200">
           <a:solidFill>
             <a:schemeClr val="tx1"/>
           </a:solidFill>
@@ -3282,16 +3282,16 @@
           <a:cs typeface="+mn-cs"/>
         </a:defRPr>
       </a:lvl2pPr>
-      <a:lvl3pPr marL="685800" indent="-137160" algn="l" defTabSz="548640" rtl="0" eaLnBrk="1" latinLnBrk="0" hangingPunct="1">
+      <a:lvl3pPr marL="1143000" indent="-228600" algn="l" defTabSz="914400" rtl="0" eaLnBrk="1" latinLnBrk="0" hangingPunct="1">
         <a:lnSpc>
           <a:spcPct val="90000"/>
         </a:lnSpc>
         <a:spcBef>
-          <a:spcPts val="300"/>
+          <a:spcPts val="500"/>
         </a:spcBef>
         <a:buFont typeface="Arial" panose="020B0604020202020204" pitchFamily="34" charset="0"/>
         <a:buChar char="•"/>
-        <a:defRPr sz="1200" kern="1200">
+        <a:defRPr sz="2000" kern="1200">
           <a:solidFill>
             <a:schemeClr val="tx1"/>
           </a:solidFill>
@@ -3300,16 +3300,16 @@
           <a:cs typeface="+mn-cs"/>
         </a:defRPr>
       </a:lvl3pPr>
-      <a:lvl4pPr marL="960120" indent="-137160" algn="l" defTabSz="548640" rtl="0" eaLnBrk="1" latinLnBrk="0" hangingPunct="1">
+      <a:lvl4pPr marL="1600200" indent="-228600" algn="l" defTabSz="914400" rtl="0" eaLnBrk="1" latinLnBrk="0" hangingPunct="1">
         <a:lnSpc>
           <a:spcPct val="90000"/>
         </a:lnSpc>
         <a:spcBef>
-          <a:spcPts val="300"/>
+          <a:spcPts val="500"/>
         </a:spcBef>
         <a:buFont typeface="Arial" panose="020B0604020202020204" pitchFamily="34" charset="0"/>
         <a:buChar char="•"/>
-        <a:defRPr sz="1080" kern="1200">
+        <a:defRPr sz="1800" kern="1200">
           <a:solidFill>
             <a:schemeClr val="tx1"/>
           </a:solidFill>
@@ -3318,16 +3318,16 @@
           <a:cs typeface="+mn-cs"/>
         </a:defRPr>
       </a:lvl4pPr>
-      <a:lvl5pPr marL="1234440" indent="-137160" algn="l" defTabSz="548640" rtl="0" eaLnBrk="1" latinLnBrk="0" hangingPunct="1">
+      <a:lvl5pPr marL="2057400" indent="-228600" algn="l" defTabSz="914400" rtl="0" eaLnBrk="1" latinLnBrk="0" hangingPunct="1">
         <a:lnSpc>
           <a:spcPct val="90000"/>
         </a:lnSpc>
         <a:spcBef>
-          <a:spcPts val="300"/>
+          <a:spcPts val="500"/>
         </a:spcBef>
         <a:buFont typeface="Arial" panose="020B0604020202020204" pitchFamily="34" charset="0"/>
         <a:buChar char="•"/>
-        <a:defRPr sz="1080" kern="1200">
+        <a:defRPr sz="1800" kern="1200">
           <a:solidFill>
             <a:schemeClr val="tx1"/>
           </a:solidFill>
@@ -3336,16 +3336,16 @@
           <a:cs typeface="+mn-cs"/>
         </a:defRPr>
       </a:lvl5pPr>
-      <a:lvl6pPr marL="1508760" indent="-137160" algn="l" defTabSz="548640" rtl="0" eaLnBrk="1" latinLnBrk="0" hangingPunct="1">
+      <a:lvl6pPr marL="2514600" indent="-228600" algn="l" defTabSz="914400" rtl="0" eaLnBrk="1" latinLnBrk="0" hangingPunct="1">
         <a:lnSpc>
           <a:spcPct val="90000"/>
         </a:lnSpc>
         <a:spcBef>
-          <a:spcPts val="300"/>
+          <a:spcPts val="500"/>
         </a:spcBef>
         <a:buFont typeface="Arial" panose="020B0604020202020204" pitchFamily="34" charset="0"/>
         <a:buChar char="•"/>
-        <a:defRPr sz="1080" kern="1200">
+        <a:defRPr sz="1800" kern="1200">
           <a:solidFill>
             <a:schemeClr val="tx1"/>
           </a:solidFill>
@@ -3354,16 +3354,16 @@
           <a:cs typeface="+mn-cs"/>
         </a:defRPr>
       </a:lvl6pPr>
-      <a:lvl7pPr marL="1783080" indent="-137160" algn="l" defTabSz="548640" rtl="0" eaLnBrk="1" latinLnBrk="0" hangingPunct="1">
+      <a:lvl7pPr marL="2971800" indent="-228600" algn="l" defTabSz="914400" rtl="0" eaLnBrk="1" latinLnBrk="0" hangingPunct="1">
         <a:lnSpc>
           <a:spcPct val="90000"/>
         </a:lnSpc>
         <a:spcBef>
-          <a:spcPts val="300"/>
+          <a:spcPts val="500"/>
         </a:spcBef>
         <a:buFont typeface="Arial" panose="020B0604020202020204" pitchFamily="34" charset="0"/>
         <a:buChar char="•"/>
-        <a:defRPr sz="1080" kern="1200">
+        <a:defRPr sz="1800" kern="1200">
           <a:solidFill>
             <a:schemeClr val="tx1"/>
           </a:solidFill>
@@ -3372,16 +3372,16 @@
           <a:cs typeface="+mn-cs"/>
         </a:defRPr>
       </a:lvl7pPr>
-      <a:lvl8pPr marL="2057400" indent="-137160" algn="l" defTabSz="548640" rtl="0" eaLnBrk="1" latinLnBrk="0" hangingPunct="1">
+      <a:lvl8pPr marL="3429000" indent="-228600" algn="l" defTabSz="914400" rtl="0" eaLnBrk="1" latinLnBrk="0" hangingPunct="1">
         <a:lnSpc>
           <a:spcPct val="90000"/>
         </a:lnSpc>
         <a:spcBef>
-          <a:spcPts val="300"/>
+          <a:spcPts val="500"/>
         </a:spcBef>
         <a:buFont typeface="Arial" panose="020B0604020202020204" pitchFamily="34" charset="0"/>
         <a:buChar char="•"/>
-        <a:defRPr sz="1080" kern="1200">
+        <a:defRPr sz="1800" kern="1200">
           <a:solidFill>
             <a:schemeClr val="tx1"/>
           </a:solidFill>
@@ -3390,16 +3390,16 @@
           <a:cs typeface="+mn-cs"/>
         </a:defRPr>
       </a:lvl8pPr>
-      <a:lvl9pPr marL="2331720" indent="-137160" algn="l" defTabSz="548640" rtl="0" eaLnBrk="1" latinLnBrk="0" hangingPunct="1">
+      <a:lvl9pPr marL="3886200" indent="-228600" algn="l" defTabSz="914400" rtl="0" eaLnBrk="1" latinLnBrk="0" hangingPunct="1">
         <a:lnSpc>
           <a:spcPct val="90000"/>
         </a:lnSpc>
         <a:spcBef>
-          <a:spcPts val="300"/>
+          <a:spcPts val="500"/>
         </a:spcBef>
         <a:buFont typeface="Arial" panose="020B0604020202020204" pitchFamily="34" charset="0"/>
         <a:buChar char="•"/>
-        <a:defRPr sz="1080" kern="1200">
+        <a:defRPr sz="1800" kern="1200">
           <a:solidFill>
             <a:schemeClr val="tx1"/>
           </a:solidFill>
@@ -3413,8 +3413,8 @@
       <a:defPPr>
         <a:defRPr lang="en-US"/>
       </a:defPPr>
-      <a:lvl1pPr marL="0" algn="l" defTabSz="548640" rtl="0" eaLnBrk="1" latinLnBrk="0" hangingPunct="1">
-        <a:defRPr sz="1080" kern="1200">
+      <a:lvl1pPr marL="0" algn="l" defTabSz="914400" rtl="0" eaLnBrk="1" latinLnBrk="0" hangingPunct="1">
+        <a:defRPr sz="1800" kern="1200">
           <a:solidFill>
             <a:schemeClr val="tx1"/>
           </a:solidFill>
@@ -3423,8 +3423,8 @@
           <a:cs typeface="+mn-cs"/>
         </a:defRPr>
       </a:lvl1pPr>
-      <a:lvl2pPr marL="274320" algn="l" defTabSz="548640" rtl="0" eaLnBrk="1" latinLnBrk="0" hangingPunct="1">
-        <a:defRPr sz="1080" kern="1200">
+      <a:lvl2pPr marL="457200" algn="l" defTabSz="914400" rtl="0" eaLnBrk="1" latinLnBrk="0" hangingPunct="1">
+        <a:defRPr sz="1800" kern="1200">
           <a:solidFill>
             <a:schemeClr val="tx1"/>
           </a:solidFill>
@@ -3433,8 +3433,8 @@
           <a:cs typeface="+mn-cs"/>
         </a:defRPr>
       </a:lvl2pPr>
-      <a:lvl3pPr marL="548640" algn="l" defTabSz="548640" rtl="0" eaLnBrk="1" latinLnBrk="0" hangingPunct="1">
-        <a:defRPr sz="1080" kern="1200">
+      <a:lvl3pPr marL="914400" algn="l" defTabSz="914400" rtl="0" eaLnBrk="1" latinLnBrk="0" hangingPunct="1">
+        <a:defRPr sz="1800" kern="1200">
           <a:solidFill>
             <a:schemeClr val="tx1"/>
           </a:solidFill>
@@ -3443,8 +3443,8 @@
           <a:cs typeface="+mn-cs"/>
         </a:defRPr>
       </a:lvl3pPr>
-      <a:lvl4pPr marL="822960" algn="l" defTabSz="548640" rtl="0" eaLnBrk="1" latinLnBrk="0" hangingPunct="1">
-        <a:defRPr sz="1080" kern="1200">
+      <a:lvl4pPr marL="1371600" algn="l" defTabSz="914400" rtl="0" eaLnBrk="1" latinLnBrk="0" hangingPunct="1">
+        <a:defRPr sz="1800" kern="1200">
           <a:solidFill>
             <a:schemeClr val="tx1"/>
           </a:solidFill>
@@ -3453,8 +3453,8 @@
           <a:cs typeface="+mn-cs"/>
         </a:defRPr>
       </a:lvl4pPr>
-      <a:lvl5pPr marL="1097280" algn="l" defTabSz="548640" rtl="0" eaLnBrk="1" latinLnBrk="0" hangingPunct="1">
-        <a:defRPr sz="1080" kern="1200">
+      <a:lvl5pPr marL="1828800" algn="l" defTabSz="914400" rtl="0" eaLnBrk="1" latinLnBrk="0" hangingPunct="1">
+        <a:defRPr sz="1800" kern="1200">
           <a:solidFill>
             <a:schemeClr val="tx1"/>
           </a:solidFill>
@@ -3463,8 +3463,8 @@
           <a:cs typeface="+mn-cs"/>
         </a:defRPr>
       </a:lvl5pPr>
-      <a:lvl6pPr marL="1371600" algn="l" defTabSz="548640" rtl="0" eaLnBrk="1" latinLnBrk="0" hangingPunct="1">
-        <a:defRPr sz="1080" kern="1200">
+      <a:lvl6pPr marL="2286000" algn="l" defTabSz="914400" rtl="0" eaLnBrk="1" latinLnBrk="0" hangingPunct="1">
+        <a:defRPr sz="1800" kern="1200">
           <a:solidFill>
             <a:schemeClr val="tx1"/>
           </a:solidFill>
@@ -3473,8 +3473,8 @@
           <a:cs typeface="+mn-cs"/>
         </a:defRPr>
       </a:lvl6pPr>
-      <a:lvl7pPr marL="1645920" algn="l" defTabSz="548640" rtl="0" eaLnBrk="1" latinLnBrk="0" hangingPunct="1">
-        <a:defRPr sz="1080" kern="1200">
+      <a:lvl7pPr marL="2743200" algn="l" defTabSz="914400" rtl="0" eaLnBrk="1" latinLnBrk="0" hangingPunct="1">
+        <a:defRPr sz="1800" kern="1200">
           <a:solidFill>
             <a:schemeClr val="tx1"/>
           </a:solidFill>
@@ -3483,8 +3483,8 @@
           <a:cs typeface="+mn-cs"/>
         </a:defRPr>
       </a:lvl7pPr>
-      <a:lvl8pPr marL="1920240" algn="l" defTabSz="548640" rtl="0" eaLnBrk="1" latinLnBrk="0" hangingPunct="1">
-        <a:defRPr sz="1080" kern="1200">
+      <a:lvl8pPr marL="3200400" algn="l" defTabSz="914400" rtl="0" eaLnBrk="1" latinLnBrk="0" hangingPunct="1">
+        <a:defRPr sz="1800" kern="1200">
           <a:solidFill>
             <a:schemeClr val="tx1"/>
           </a:solidFill>
@@ -3493,8 +3493,8 @@
           <a:cs typeface="+mn-cs"/>
         </a:defRPr>
       </a:lvl8pPr>
-      <a:lvl9pPr marL="2194560" algn="l" defTabSz="548640" rtl="0" eaLnBrk="1" latinLnBrk="0" hangingPunct="1">
-        <a:defRPr sz="1080" kern="1200">
+      <a:lvl9pPr marL="3657600" algn="l" defTabSz="914400" rtl="0" eaLnBrk="1" latinLnBrk="0" hangingPunct="1">
+        <a:defRPr sz="1800" kern="1200">
           <a:solidFill>
             <a:schemeClr val="tx1"/>
           </a:solidFill>
@@ -3530,7 +3530,7 @@
           <p:cNvPr id="2" name="Title 1">
             <a:extLst>
               <a:ext uri="{FF2B5EF4-FFF2-40B4-BE49-F238E27FC236}">
-                <a16:creationId xmlns:a16="http://schemas.microsoft.com/office/drawing/2014/main" id="{1F7EC0BF-A76A-FE38-70A7-030BED666601}"/>
+                <a16:creationId xmlns:a16="http://schemas.microsoft.com/office/drawing/2014/main" id="{38BCF5A7-A96C-5C55-BC9A-07D01E191D99}"/>
               </a:ext>
             </a:extLst>
           </p:cNvPr>
@@ -3558,7 +3558,7 @@
           <p:cNvPr id="3" name="Subtitle 2">
             <a:extLst>
               <a:ext uri="{FF2B5EF4-FFF2-40B4-BE49-F238E27FC236}">
-                <a16:creationId xmlns:a16="http://schemas.microsoft.com/office/drawing/2014/main" id="{14274E92-31F8-F3A9-5DAD-E6337C8BE2FD}"/>
+                <a16:creationId xmlns:a16="http://schemas.microsoft.com/office/drawing/2014/main" id="{6FD8D0C9-D4A3-A2AF-370D-EAB91B05CE69}"/>
               </a:ext>
             </a:extLst>
           </p:cNvPr>
@@ -3585,7 +3585,7 @@
     </p:spTree>
     <p:extLst>
       <p:ext uri="{BB962C8B-B14F-4D97-AF65-F5344CB8AC3E}">
-        <p14:creationId xmlns:p14="http://schemas.microsoft.com/office/powerpoint/2010/main" val="509905096"/>
+        <p14:creationId xmlns:p14="http://schemas.microsoft.com/office/powerpoint/2010/main" val="3618252628"/>
       </p:ext>
     </p:extLst>
   </p:cSld>
@@ -3617,7 +3617,7 @@
           <p:cNvPr id="2" name="Title 1">
             <a:extLst>
               <a:ext uri="{FF2B5EF4-FFF2-40B4-BE49-F238E27FC236}">
-                <a16:creationId xmlns:a16="http://schemas.microsoft.com/office/drawing/2014/main" id="{4770F39D-A68A-3154-A813-AB8E1F3FA3C6}"/>
+                <a16:creationId xmlns:a16="http://schemas.microsoft.com/office/drawing/2014/main" id="{AE3D6CC2-55CD-243C-9A5D-1AA9DF28F1D1}"/>
               </a:ext>
             </a:extLst>
           </p:cNvPr>
@@ -3645,7 +3645,7 @@
           <p:cNvPr id="3" name="Text Placeholder 2">
             <a:extLst>
               <a:ext uri="{FF2B5EF4-FFF2-40B4-BE49-F238E27FC236}">
-                <a16:creationId xmlns:a16="http://schemas.microsoft.com/office/drawing/2014/main" id="{F46100B3-74EA-B457-499D-FD8D19CBAC5A}"/>
+                <a16:creationId xmlns:a16="http://schemas.microsoft.com/office/drawing/2014/main" id="{9A752C1D-DEA2-007D-D467-347C503341B6}"/>
               </a:ext>
             </a:extLst>
           </p:cNvPr>
@@ -3674,7 +3674,7 @@
     </p:spTree>
     <p:extLst>
       <p:ext uri="{BB962C8B-B14F-4D97-AF65-F5344CB8AC3E}">
-        <p14:creationId xmlns:p14="http://schemas.microsoft.com/office/powerpoint/2010/main" val="2010391088"/>
+        <p14:creationId xmlns:p14="http://schemas.microsoft.com/office/powerpoint/2010/main" val="520208066"/>
       </p:ext>
     </p:extLst>
   </p:cSld>
@@ -3706,7 +3706,7 @@
           <p:cNvPr id="2" name="Title 1">
             <a:extLst>
               <a:ext uri="{FF2B5EF4-FFF2-40B4-BE49-F238E27FC236}">
-                <a16:creationId xmlns:a16="http://schemas.microsoft.com/office/drawing/2014/main" id="{E5C00D83-8D98-D6EE-2075-EE862CC50812}"/>
+                <a16:creationId xmlns:a16="http://schemas.microsoft.com/office/drawing/2014/main" id="{32794DE3-85E4-7299-A653-D5B2EE2B0242}"/>
               </a:ext>
             </a:extLst>
           </p:cNvPr>
@@ -3734,7 +3734,7 @@
           <p:cNvPr id="3" name="Text Placeholder 2">
             <a:extLst>
               <a:ext uri="{FF2B5EF4-FFF2-40B4-BE49-F238E27FC236}">
-                <a16:creationId xmlns:a16="http://schemas.microsoft.com/office/drawing/2014/main" id="{24B9FDBB-883C-B31A-EAD8-C35C34BCD2D3}"/>
+                <a16:creationId xmlns:a16="http://schemas.microsoft.com/office/drawing/2014/main" id="{7B36684B-750D-2B9F-BBA5-9E78465A0C0E}"/>
               </a:ext>
             </a:extLst>
           </p:cNvPr>
@@ -3762,7 +3762,7 @@
     </p:spTree>
     <p:extLst>
       <p:ext uri="{BB962C8B-B14F-4D97-AF65-F5344CB8AC3E}">
-        <p14:creationId xmlns:p14="http://schemas.microsoft.com/office/powerpoint/2010/main" val="1566492047"/>
+        <p14:creationId xmlns:p14="http://schemas.microsoft.com/office/powerpoint/2010/main" val="1844473102"/>
       </p:ext>
     </p:extLst>
   </p:cSld>
@@ -3794,7 +3794,7 @@
           <p:cNvPr id="2" name="Title 1">
             <a:extLst>
               <a:ext uri="{FF2B5EF4-FFF2-40B4-BE49-F238E27FC236}">
-                <a16:creationId xmlns:a16="http://schemas.microsoft.com/office/drawing/2014/main" id="{4F7CC924-6DDB-E3F4-A8D6-174A4B18B00B}"/>
+                <a16:creationId xmlns:a16="http://schemas.microsoft.com/office/drawing/2014/main" id="{46F3CF93-1A2E-9561-67A2-7A894172E2AE}"/>
               </a:ext>
             </a:extLst>
           </p:cNvPr>
@@ -3822,7 +3822,7 @@
           <p:cNvPr id="3" name="Text Placeholder 2">
             <a:extLst>
               <a:ext uri="{FF2B5EF4-FFF2-40B4-BE49-F238E27FC236}">
-                <a16:creationId xmlns:a16="http://schemas.microsoft.com/office/drawing/2014/main" id="{BCF3088E-ADE2-512F-261A-307688861E96}"/>
+                <a16:creationId xmlns:a16="http://schemas.microsoft.com/office/drawing/2014/main" id="{74DCF905-A79A-58FC-8F62-A0FB324DD799}"/>
               </a:ext>
             </a:extLst>
           </p:cNvPr>
@@ -3850,7 +3850,7 @@
           <p:cNvPr id="4" name="Content Placeholder 3">
             <a:extLst>
               <a:ext uri="{FF2B5EF4-FFF2-40B4-BE49-F238E27FC236}">
-                <a16:creationId xmlns:a16="http://schemas.microsoft.com/office/drawing/2014/main" id="{8702E226-37C5-D968-4624-6E024EA1DA8D}"/>
+                <a16:creationId xmlns:a16="http://schemas.microsoft.com/office/drawing/2014/main" id="{DBC6418E-928A-6CCF-9600-A770226141A7}"/>
               </a:ext>
             </a:extLst>
           </p:cNvPr>
@@ -3881,7 +3881,7 @@
           <p:cNvPr id="5" name="Text Placeholder 4">
             <a:extLst>
               <a:ext uri="{FF2B5EF4-FFF2-40B4-BE49-F238E27FC236}">
-                <a16:creationId xmlns:a16="http://schemas.microsoft.com/office/drawing/2014/main" id="{5261BE37-681A-6DAC-4323-2B3141D56506}"/>
+                <a16:creationId xmlns:a16="http://schemas.microsoft.com/office/drawing/2014/main" id="{4A74F0CD-1131-E039-4191-DACEAEA19F46}"/>
               </a:ext>
             </a:extLst>
           </p:cNvPr>
@@ -3909,7 +3909,7 @@
           <p:cNvPr id="6" name="Content Placeholder 5">
             <a:extLst>
               <a:ext uri="{FF2B5EF4-FFF2-40B4-BE49-F238E27FC236}">
-                <a16:creationId xmlns:a16="http://schemas.microsoft.com/office/drawing/2014/main" id="{4E34A8C8-214B-7F44-E383-E1ADDFEE9FB3}"/>
+                <a16:creationId xmlns:a16="http://schemas.microsoft.com/office/drawing/2014/main" id="{5B4F6244-3392-0273-FA09-FC127F1F6B79}"/>
               </a:ext>
             </a:extLst>
           </p:cNvPr>
@@ -3938,7 +3938,7 @@
     </p:spTree>
     <p:extLst>
       <p:ext uri="{BB962C8B-B14F-4D97-AF65-F5344CB8AC3E}">
-        <p14:creationId xmlns:p14="http://schemas.microsoft.com/office/powerpoint/2010/main" val="166052100"/>
+        <p14:creationId xmlns:p14="http://schemas.microsoft.com/office/powerpoint/2010/main" val="2214886192"/>
       </p:ext>
     </p:extLst>
   </p:cSld>
@@ -3970,7 +3970,7 @@
           <p:cNvPr id="2" name="Title 1">
             <a:extLst>
               <a:ext uri="{FF2B5EF4-FFF2-40B4-BE49-F238E27FC236}">
-                <a16:creationId xmlns:a16="http://schemas.microsoft.com/office/drawing/2014/main" id="{8D1B6ABC-A726-17CA-52D0-6AF46ACDF3C2}"/>
+                <a16:creationId xmlns:a16="http://schemas.microsoft.com/office/drawing/2014/main" id="{041FA08D-4C23-329F-5653-4DC4407A0AE4}"/>
               </a:ext>
             </a:extLst>
           </p:cNvPr>
@@ -3998,7 +3998,7 @@
           <p:cNvPr id="3" name="Text Placeholder 2">
             <a:extLst>
               <a:ext uri="{FF2B5EF4-FFF2-40B4-BE49-F238E27FC236}">
-                <a16:creationId xmlns:a16="http://schemas.microsoft.com/office/drawing/2014/main" id="{FEFCDEDB-090D-E088-3788-912BBC3ADC3A}"/>
+                <a16:creationId xmlns:a16="http://schemas.microsoft.com/office/drawing/2014/main" id="{15D6DC49-82E1-F308-D093-38ECA4158D1A}"/>
               </a:ext>
             </a:extLst>
           </p:cNvPr>
@@ -4027,7 +4027,7 @@
     </p:spTree>
     <p:extLst>
       <p:ext uri="{BB962C8B-B14F-4D97-AF65-F5344CB8AC3E}">
-        <p14:creationId xmlns:p14="http://schemas.microsoft.com/office/powerpoint/2010/main" val="978868707"/>
+        <p14:creationId xmlns:p14="http://schemas.microsoft.com/office/powerpoint/2010/main" val="1829902831"/>
       </p:ext>
     </p:extLst>
   </p:cSld>
@@ -4059,7 +4059,7 @@
           <p:cNvPr id="2" name="Title 1">
             <a:extLst>
               <a:ext uri="{FF2B5EF4-FFF2-40B4-BE49-F238E27FC236}">
-                <a16:creationId xmlns:a16="http://schemas.microsoft.com/office/drawing/2014/main" id="{F705FC50-EBB2-1075-27CE-D3FE9A3A7064}"/>
+                <a16:creationId xmlns:a16="http://schemas.microsoft.com/office/drawing/2014/main" id="{F51F443F-F1A0-2A1A-676D-926606E27AAD}"/>
               </a:ext>
             </a:extLst>
           </p:cNvPr>
@@ -4087,7 +4087,7 @@
           <p:cNvPr id="3" name="Text Placeholder 2">
             <a:extLst>
               <a:ext uri="{FF2B5EF4-FFF2-40B4-BE49-F238E27FC236}">
-                <a16:creationId xmlns:a16="http://schemas.microsoft.com/office/drawing/2014/main" id="{341E4901-2006-5E22-6E86-6AB2211BEC30}"/>
+                <a16:creationId xmlns:a16="http://schemas.microsoft.com/office/drawing/2014/main" id="{BBBC43E4-433F-8AD1-3211-517D041F2701}"/>
               </a:ext>
             </a:extLst>
           </p:cNvPr>
@@ -4115,7 +4115,7 @@
     </p:spTree>
     <p:extLst>
       <p:ext uri="{BB962C8B-B14F-4D97-AF65-F5344CB8AC3E}">
-        <p14:creationId xmlns:p14="http://schemas.microsoft.com/office/powerpoint/2010/main" val="2266266912"/>
+        <p14:creationId xmlns:p14="http://schemas.microsoft.com/office/powerpoint/2010/main" val="2680072106"/>
       </p:ext>
     </p:extLst>
   </p:cSld>

</xml_diff>